<commit_message>
Add sparse icons to PPTX, matching the web deck
Co-Authored-By: Claude Sonnet 5.5 <noreply@anthropic.com>
Claude-Session: https://claude.ai/code/session_01XNTjksxVUQQ2s2meKajJig
</commit_message>
<xml_diff>
--- a/Presentation_RIPTIS.pptx
+++ b/Presentation_RIPTIS.pptx
@@ -3037,9 +3037,33 @@
           </a:p>
         </p:txBody>
       </p:sp>
-      <p:sp>
-        <p:nvSpPr>
-          <p:cNvPr id="15" name="Shape 10"/>
+      <p:pic>
+        <p:nvPicPr>
+          <p:cNvPr id="15" name="Image 2" descr="../img/ic_lock_b.png">    </p:cNvPr>
+          <p:cNvPicPr>
+            <a:picLocks noChangeAspect="1"/>
+          </p:cNvPicPr>
+          <p:nvPr/>
+        </p:nvPicPr>
+        <p:blipFill>
+          <a:blip r:embed="rId3"/>
+          <a:stretch>
+            <a:fillRect/>
+          </a:stretch>
+        </p:blipFill>
+        <p:spPr>
+          <a:xfrm>
+            <a:off x="5435600" y="1778000"/>
+            <a:ext cx="304800" cy="304800"/>
+          </a:xfrm>
+          <a:prstGeom prst="rect">
+            <a:avLst/>
+          </a:prstGeom>
+        </p:spPr>
+      </p:pic>
+      <p:sp>
+        <p:nvSpPr>
+          <p:cNvPr id="16" name="Shape 10"/>
           <p:cNvSpPr/>
           <p:nvPr/>
         </p:nvSpPr>
@@ -3071,7 +3095,7 @@
       </p:sp>
       <p:sp>
         <p:nvSpPr>
-          <p:cNvPr id="16" name="Text 11"/>
+          <p:cNvPr id="17" name="Text 11"/>
           <p:cNvSpPr txBox="1"/>
           <p:nvPr/>
         </p:nvSpPr>
@@ -3110,7 +3134,7 @@
       </p:sp>
       <p:sp>
         <p:nvSpPr>
-          <p:cNvPr id="17" name="Text 12"/>
+          <p:cNvPr id="18" name="Text 12"/>
           <p:cNvSpPr txBox="1"/>
           <p:nvPr/>
         </p:nvSpPr>
@@ -3149,7 +3173,7 @@
       </p:sp>
       <p:sp>
         <p:nvSpPr>
-          <p:cNvPr id="18" name="Text 13"/>
+          <p:cNvPr id="19" name="Text 13"/>
           <p:cNvSpPr txBox="1"/>
           <p:nvPr/>
         </p:nvSpPr>
@@ -3189,9 +3213,33 @@
           </a:p>
         </p:txBody>
       </p:sp>
-      <p:sp>
-        <p:nvSpPr>
-          <p:cNvPr id="19" name="Shape 14"/>
+      <p:pic>
+        <p:nvPicPr>
+          <p:cNvPr id="20" name="Image 3" descr="../img/ic_database_b.png">    </p:cNvPr>
+          <p:cNvPicPr>
+            <a:picLocks noChangeAspect="1"/>
+          </p:cNvPicPr>
+          <p:nvPr/>
+        </p:nvPicPr>
+        <p:blipFill>
+          <a:blip r:embed="rId4"/>
+          <a:stretch>
+            <a:fillRect/>
+          </a:stretch>
+        </p:blipFill>
+        <p:spPr>
+          <a:xfrm>
+            <a:off x="10845800" y="1778000"/>
+            <a:ext cx="304800" cy="304800"/>
+          </a:xfrm>
+          <a:prstGeom prst="rect">
+            <a:avLst/>
+          </a:prstGeom>
+        </p:spPr>
+      </p:pic>
+      <p:sp>
+        <p:nvSpPr>
+          <p:cNvPr id="21" name="Shape 14"/>
           <p:cNvSpPr/>
           <p:nvPr/>
         </p:nvSpPr>
@@ -3211,7 +3259,7 @@
       </p:sp>
       <p:sp>
         <p:nvSpPr>
-          <p:cNvPr id="20" name="Text 15"/>
+          <p:cNvPr id="22" name="Text 15"/>
           <p:cNvSpPr txBox="1"/>
           <p:nvPr/>
         </p:nvSpPr>
@@ -6486,9 +6534,33 @@
           </a:p>
         </p:txBody>
       </p:sp>
-      <p:sp>
-        <p:nvSpPr>
-          <p:cNvPr id="14" name="Shape 9"/>
+      <p:pic>
+        <p:nvPicPr>
+          <p:cNvPr id="14" name="Image 2" descr="../img/ic_code_b.png">    </p:cNvPr>
+          <p:cNvPicPr>
+            <a:picLocks noChangeAspect="1"/>
+          </p:cNvPicPr>
+          <p:nvPr/>
+        </p:nvPicPr>
+        <p:blipFill>
+          <a:blip r:embed="rId3"/>
+          <a:stretch>
+            <a:fillRect/>
+          </a:stretch>
+        </p:blipFill>
+        <p:spPr>
+          <a:xfrm>
+            <a:off x="5435600" y="1790700"/>
+            <a:ext cx="304800" cy="304800"/>
+          </a:xfrm>
+          <a:prstGeom prst="rect">
+            <a:avLst/>
+          </a:prstGeom>
+        </p:spPr>
+      </p:pic>
+      <p:sp>
+        <p:nvSpPr>
+          <p:cNvPr id="15" name="Shape 9"/>
           <p:cNvSpPr/>
           <p:nvPr/>
         </p:nvSpPr>
@@ -6518,9 +6590,33 @@
           </a:effectLst>
         </p:spPr>
       </p:sp>
-      <p:sp>
-        <p:nvSpPr>
-          <p:cNvPr id="15" name="Text 10"/>
+      <p:pic>
+        <p:nvPicPr>
+          <p:cNvPr id="16" name="Image 3" descr="../img/ic_bulb_p.png">    </p:cNvPr>
+          <p:cNvPicPr>
+            <a:picLocks noChangeAspect="1"/>
+          </p:cNvPicPr>
+          <p:nvPr/>
+        </p:nvPicPr>
+        <p:blipFill>
+          <a:blip r:embed="rId4"/>
+          <a:stretch>
+            <a:fillRect/>
+          </a:stretch>
+        </p:blipFill>
+        <p:spPr>
+          <a:xfrm>
+            <a:off x="10845800" y="1790700"/>
+            <a:ext cx="304800" cy="304800"/>
+          </a:xfrm>
+          <a:prstGeom prst="rect">
+            <a:avLst/>
+          </a:prstGeom>
+        </p:spPr>
+      </p:pic>
+      <p:sp>
+        <p:nvSpPr>
+          <p:cNvPr id="17" name="Text 10"/>
           <p:cNvSpPr txBox="1"/>
           <p:nvPr/>
         </p:nvSpPr>
@@ -6559,7 +6655,7 @@
       </p:sp>
       <p:sp>
         <p:nvSpPr>
-          <p:cNvPr id="16" name="Text 11"/>
+          <p:cNvPr id="18" name="Text 11"/>
           <p:cNvSpPr txBox="1"/>
           <p:nvPr/>
         </p:nvSpPr>
@@ -6601,7 +6697,7 @@
       </p:sp>
       <p:sp>
         <p:nvSpPr>
-          <p:cNvPr id="17" name="Text 12"/>
+          <p:cNvPr id="19" name="Text 12"/>
           <p:cNvSpPr txBox="1"/>
           <p:nvPr/>
         </p:nvSpPr>
@@ -8599,9 +8695,33 @@
           </a:p>
         </p:txBody>
       </p:sp>
-      <p:sp>
-        <p:nvSpPr>
-          <p:cNvPr id="15" name="Shape 10"/>
+      <p:pic>
+        <p:nvPicPr>
+          <p:cNvPr id="15" name="Image 2" descr="../img/ic_globe_b.png">    </p:cNvPr>
+          <p:cNvPicPr>
+            <a:picLocks noChangeAspect="1"/>
+          </p:cNvPicPr>
+          <p:nvPr/>
+        </p:nvPicPr>
+        <p:blipFill>
+          <a:blip r:embed="rId3"/>
+          <a:stretch>
+            <a:fillRect/>
+          </a:stretch>
+        </p:blipFill>
+        <p:spPr>
+          <a:xfrm>
+            <a:off x="2768600" y="2095500"/>
+            <a:ext cx="304800" cy="304800"/>
+          </a:xfrm>
+          <a:prstGeom prst="rect">
+            <a:avLst/>
+          </a:prstGeom>
+        </p:spPr>
+      </p:pic>
+      <p:sp>
+        <p:nvSpPr>
+          <p:cNvPr id="16" name="Shape 10"/>
           <p:cNvSpPr/>
           <p:nvPr/>
         </p:nvSpPr>
@@ -8633,7 +8753,7 @@
       </p:sp>
       <p:sp>
         <p:nvSpPr>
-          <p:cNvPr id="16" name="Text 11"/>
+          <p:cNvPr id="17" name="Text 11"/>
           <p:cNvSpPr txBox="1"/>
           <p:nvPr/>
         </p:nvSpPr>
@@ -8672,7 +8792,7 @@
       </p:sp>
       <p:sp>
         <p:nvSpPr>
-          <p:cNvPr id="17" name="Text 12"/>
+          <p:cNvPr id="18" name="Text 12"/>
           <p:cNvSpPr txBox="1"/>
           <p:nvPr/>
         </p:nvSpPr>
@@ -8711,7 +8831,7 @@
       </p:sp>
       <p:sp>
         <p:nvSpPr>
-          <p:cNvPr id="18" name="Text 13"/>
+          <p:cNvPr id="19" name="Text 13"/>
           <p:cNvSpPr txBox="1"/>
           <p:nvPr/>
         </p:nvSpPr>
@@ -8751,9 +8871,33 @@
           </a:p>
         </p:txBody>
       </p:sp>
-      <p:sp>
-        <p:nvSpPr>
-          <p:cNvPr id="19" name="Shape 14"/>
+      <p:pic>
+        <p:nvPicPr>
+          <p:cNvPr id="20" name="Image 3" descr="../img/ic_settings_b.png">    </p:cNvPr>
+          <p:cNvPicPr>
+            <a:picLocks noChangeAspect="1"/>
+          </p:cNvPicPr>
+          <p:nvPr/>
+        </p:nvPicPr>
+        <p:blipFill>
+          <a:blip r:embed="rId4"/>
+          <a:stretch>
+            <a:fillRect/>
+          </a:stretch>
+        </p:blipFill>
+        <p:spPr>
+          <a:xfrm>
+            <a:off x="5461000" y="2095500"/>
+            <a:ext cx="304800" cy="304800"/>
+          </a:xfrm>
+          <a:prstGeom prst="rect">
+            <a:avLst/>
+          </a:prstGeom>
+        </p:spPr>
+      </p:pic>
+      <p:sp>
+        <p:nvSpPr>
+          <p:cNvPr id="21" name="Shape 14"/>
           <p:cNvSpPr/>
           <p:nvPr/>
         </p:nvSpPr>
@@ -8785,7 +8929,7 @@
       </p:sp>
       <p:sp>
         <p:nvSpPr>
-          <p:cNvPr id="20" name="Text 15"/>
+          <p:cNvPr id="22" name="Text 15"/>
           <p:cNvSpPr txBox="1"/>
           <p:nvPr/>
         </p:nvSpPr>
@@ -8824,7 +8968,7 @@
       </p:sp>
       <p:sp>
         <p:nvSpPr>
-          <p:cNvPr id="21" name="Text 16"/>
+          <p:cNvPr id="23" name="Text 16"/>
           <p:cNvSpPr txBox="1"/>
           <p:nvPr/>
         </p:nvSpPr>
@@ -8863,7 +9007,7 @@
       </p:sp>
       <p:sp>
         <p:nvSpPr>
-          <p:cNvPr id="22" name="Text 17"/>
+          <p:cNvPr id="24" name="Text 17"/>
           <p:cNvSpPr txBox="1"/>
           <p:nvPr/>
         </p:nvSpPr>
@@ -8903,9 +9047,33 @@
           </a:p>
         </p:txBody>
       </p:sp>
-      <p:sp>
-        <p:nvSpPr>
-          <p:cNvPr id="23" name="Shape 18"/>
+      <p:pic>
+        <p:nvPicPr>
+          <p:cNvPr id="25" name="Image 4" descr="../img/ic_chart_b.png">    </p:cNvPr>
+          <p:cNvPicPr>
+            <a:picLocks noChangeAspect="1"/>
+          </p:cNvPicPr>
+          <p:nvPr/>
+        </p:nvPicPr>
+        <p:blipFill>
+          <a:blip r:embed="rId5"/>
+          <a:stretch>
+            <a:fillRect/>
+          </a:stretch>
+        </p:blipFill>
+        <p:spPr>
+          <a:xfrm>
+            <a:off x="8153400" y="2095500"/>
+            <a:ext cx="304800" cy="304800"/>
+          </a:xfrm>
+          <a:prstGeom prst="rect">
+            <a:avLst/>
+          </a:prstGeom>
+        </p:spPr>
+      </p:pic>
+      <p:sp>
+        <p:nvSpPr>
+          <p:cNvPr id="26" name="Shape 18"/>
           <p:cNvSpPr/>
           <p:nvPr/>
         </p:nvSpPr>
@@ -8937,7 +9105,7 @@
       </p:sp>
       <p:sp>
         <p:nvSpPr>
-          <p:cNvPr id="24" name="Text 19"/>
+          <p:cNvPr id="27" name="Text 19"/>
           <p:cNvSpPr txBox="1"/>
           <p:nvPr/>
         </p:nvSpPr>
@@ -8976,7 +9144,7 @@
       </p:sp>
       <p:sp>
         <p:nvSpPr>
-          <p:cNvPr id="25" name="Text 20"/>
+          <p:cNvPr id="28" name="Text 20"/>
           <p:cNvSpPr txBox="1"/>
           <p:nvPr/>
         </p:nvSpPr>
@@ -9015,7 +9183,7 @@
       </p:sp>
       <p:sp>
         <p:nvSpPr>
-          <p:cNvPr id="26" name="Text 21"/>
+          <p:cNvPr id="29" name="Text 21"/>
           <p:cNvSpPr txBox="1"/>
           <p:nvPr/>
         </p:nvSpPr>
@@ -9055,6 +9223,30 @@
           </a:p>
         </p:txBody>
       </p:sp>
+      <p:pic>
+        <p:nvPicPr>
+          <p:cNvPr id="30" name="Image 5" descr="../img/ic_check_b.png">    </p:cNvPr>
+          <p:cNvPicPr>
+            <a:picLocks noChangeAspect="1"/>
+          </p:cNvPicPr>
+          <p:nvPr/>
+        </p:nvPicPr>
+        <p:blipFill>
+          <a:blip r:embed="rId6"/>
+          <a:stretch>
+            <a:fillRect/>
+          </a:stretch>
+        </p:blipFill>
+        <p:spPr>
+          <a:xfrm>
+            <a:off x="10845800" y="2095500"/>
+            <a:ext cx="304800" cy="304800"/>
+          </a:xfrm>
+          <a:prstGeom prst="rect">
+            <a:avLst/>
+          </a:prstGeom>
+        </p:spPr>
+      </p:pic>
     </p:spTree>
   </p:cSld>
   <p:clrMapOvr>
@@ -9461,9 +9653,33 @@
           </a:p>
         </p:txBody>
       </p:sp>
-      <p:sp>
-        <p:nvSpPr>
-          <p:cNvPr id="14" name="Shape 9"/>
+      <p:pic>
+        <p:nvPicPr>
+          <p:cNvPr id="14" name="Image 2" descr="../img/ic_trust_b.png">    </p:cNvPr>
+          <p:cNvPicPr>
+            <a:picLocks noChangeAspect="1"/>
+          </p:cNvPicPr>
+          <p:nvPr/>
+        </p:nvPicPr>
+        <p:blipFill>
+          <a:blip r:embed="rId3"/>
+          <a:stretch>
+            <a:fillRect/>
+          </a:stretch>
+        </p:blipFill>
+        <p:spPr>
+          <a:xfrm>
+            <a:off x="3581400" y="2324100"/>
+            <a:ext cx="355600" cy="355600"/>
+          </a:xfrm>
+          <a:prstGeom prst="rect">
+            <a:avLst/>
+          </a:prstGeom>
+        </p:spPr>
+      </p:pic>
+      <p:sp>
+        <p:nvSpPr>
+          <p:cNvPr id="15" name="Shape 9"/>
           <p:cNvSpPr/>
           <p:nvPr/>
         </p:nvSpPr>
@@ -9495,7 +9711,7 @@
       </p:sp>
       <p:sp>
         <p:nvSpPr>
-          <p:cNvPr id="15" name="Text 10"/>
+          <p:cNvPr id="16" name="Text 10"/>
           <p:cNvSpPr txBox="1"/>
           <p:nvPr/>
         </p:nvSpPr>
@@ -9534,7 +9750,7 @@
       </p:sp>
       <p:sp>
         <p:nvSpPr>
-          <p:cNvPr id="16" name="Text 11"/>
+          <p:cNvPr id="17" name="Text 11"/>
           <p:cNvSpPr txBox="1"/>
           <p:nvPr/>
         </p:nvSpPr>
@@ -9574,9 +9790,33 @@
           </a:p>
         </p:txBody>
       </p:sp>
-      <p:sp>
-        <p:nvSpPr>
-          <p:cNvPr id="17" name="Shape 12"/>
+      <p:pic>
+        <p:nvPicPr>
+          <p:cNvPr id="18" name="Image 3" descr="../img/ic_database_b.png">    </p:cNvPr>
+          <p:cNvPicPr>
+            <a:picLocks noChangeAspect="1"/>
+          </p:cNvPicPr>
+          <p:nvPr/>
+        </p:nvPicPr>
+        <p:blipFill>
+          <a:blip r:embed="rId4"/>
+          <a:stretch>
+            <a:fillRect/>
+          </a:stretch>
+        </p:blipFill>
+        <p:spPr>
+          <a:xfrm>
+            <a:off x="7188200" y="2324100"/>
+            <a:ext cx="355600" cy="355600"/>
+          </a:xfrm>
+          <a:prstGeom prst="rect">
+            <a:avLst/>
+          </a:prstGeom>
+        </p:spPr>
+      </p:pic>
+      <p:sp>
+        <p:nvSpPr>
+          <p:cNvPr id="19" name="Shape 12"/>
           <p:cNvSpPr/>
           <p:nvPr/>
         </p:nvSpPr>
@@ -9608,7 +9848,7 @@
       </p:sp>
       <p:sp>
         <p:nvSpPr>
-          <p:cNvPr id="18" name="Text 13"/>
+          <p:cNvPr id="20" name="Text 13"/>
           <p:cNvSpPr txBox="1"/>
           <p:nvPr/>
         </p:nvSpPr>
@@ -9647,7 +9887,7 @@
       </p:sp>
       <p:sp>
         <p:nvSpPr>
-          <p:cNvPr id="19" name="Text 14"/>
+          <p:cNvPr id="21" name="Text 14"/>
           <p:cNvSpPr txBox="1"/>
           <p:nvPr/>
         </p:nvSpPr>
@@ -9687,9 +9927,33 @@
           </a:p>
         </p:txBody>
       </p:sp>
-      <p:sp>
-        <p:nvSpPr>
-          <p:cNvPr id="20" name="Text 15"/>
+      <p:pic>
+        <p:nvPicPr>
+          <p:cNvPr id="22" name="Image 4" descr="../img/ic_clock_b.png">    </p:cNvPr>
+          <p:cNvPicPr>
+            <a:picLocks noChangeAspect="1"/>
+          </p:cNvPicPr>
+          <p:nvPr/>
+        </p:nvPicPr>
+        <p:blipFill>
+          <a:blip r:embed="rId5"/>
+          <a:stretch>
+            <a:fillRect/>
+          </a:stretch>
+        </p:blipFill>
+        <p:spPr>
+          <a:xfrm>
+            <a:off x="10795000" y="2324100"/>
+            <a:ext cx="355600" cy="355600"/>
+          </a:xfrm>
+          <a:prstGeom prst="rect">
+            <a:avLst/>
+          </a:prstGeom>
+        </p:spPr>
+      </p:pic>
+      <p:sp>
+        <p:nvSpPr>
+          <p:cNvPr id="23" name="Text 15"/>
           <p:cNvSpPr txBox="1"/>
           <p:nvPr/>
         </p:nvSpPr>

</xml_diff>

<commit_message>
Perspectives: uniform row height, compact VALIDÉ tag
Co-Authored-By: Claude Sonnet 5.5 <noreply@anthropic.com>
Claude-Session: https://claude.ai/code/session_01XNTjksxVUQQ2s2meKajJig
</commit_message>
<xml_diff>
--- a/Presentation_RIPTIS.pptx
+++ b/Presentation_RIPTIS.pptx
@@ -7440,7 +7440,7 @@
                 <a:ea typeface="IBM Plex Sans" pitchFamily="34" charset="-122"/>
                 <a:cs typeface="IBM Plex Sans" pitchFamily="34" charset="-120"/>
               </a:rPr>
-              <a:t>Formaliser la politique de sauvegarde (fréquence, conservation, tests de restauration)</a:t>
+              <a:t>Formaliser la sauvegarde : fréquence, conservation, restauration</a:t>
             </a:r>
             <a:endParaRPr lang="en-US" sz="1600" dirty="0"/>
           </a:p>
@@ -7454,8 +7454,8 @@
         </p:nvSpPr>
         <p:spPr>
           <a:xfrm>
-            <a:off x="9931400" y="3898900"/>
-            <a:ext cx="1270000" cy="406400"/>
+            <a:off x="10185400" y="3949700"/>
+            <a:ext cx="1016000" cy="304800"/>
           </a:xfrm>
           <a:prstGeom prst="rect">
             <a:avLst/>
@@ -7474,8 +7474,8 @@
         </p:nvSpPr>
         <p:spPr>
           <a:xfrm>
-            <a:off x="9931400" y="3898900"/>
-            <a:ext cx="1270000" cy="406400"/>
+            <a:off x="10185400" y="3949700"/>
+            <a:ext cx="1016000" cy="304800"/>
           </a:xfrm>
           <a:prstGeom prst="rect">
             <a:avLst/>
@@ -7641,8 +7641,8 @@
         </p:nvSpPr>
         <p:spPr>
           <a:xfrm>
-            <a:off x="9931400" y="4635500"/>
-            <a:ext cx="1270000" cy="406400"/>
+            <a:off x="10185400" y="4686300"/>
+            <a:ext cx="1016000" cy="304800"/>
           </a:xfrm>
           <a:prstGeom prst="rect">
             <a:avLst/>
@@ -7661,8 +7661,8 @@
         </p:nvSpPr>
         <p:spPr>
           <a:xfrm>
-            <a:off x="9931400" y="4635500"/>
-            <a:ext cx="1270000" cy="406400"/>
+            <a:off x="10185400" y="4686300"/>
+            <a:ext cx="1016000" cy="304800"/>
           </a:xfrm>
           <a:prstGeom prst="rect">
             <a:avLst/>

</xml_diff>

<commit_message>
Reorder slides: démarche (planning, imprévus) before résultats
Co-Authored-By: Claude Sonnet 5.5 <noreply@anthropic.com>
Claude-Session: https://claude.ai/code/session_01XNTjksxVUQQ2s2meKajJig
</commit_message>
<xml_diff>
--- a/Presentation_RIPTIS.pptx
+++ b/Presentation_RIPTIS.pptx
@@ -604,7 +604,7 @@
           <a:p>
             <a:r>
               <a:rPr lang="en-US" dirty="0"/>
-              <a:t>Le premier imprévu a été limité par une demande d’accès anticipée. Le second m’a conduit à généraliser le moteur d’import plutôt que traiter les fichiers un par un : c’est ce choix qui explique le mois de retard, validé avec mon maître d’apprentissage.</a:t>
+              <a:t>Cas réel, identifiants masqués : une recherche d’adresse IP sur l’ensemble de la base retourne instantanément les deux fichiers concernés, avec la route correspondante. La recherche DNS enrichit les résultats.</a:t>
             </a:r>
             <a:endParaRPr lang="en-US" dirty="0"/>
           </a:p>
@@ -1572,7 +1572,7 @@
           <a:p>
             <a:r>
               <a:rPr lang="en-US" dirty="0"/>
-              <a:t>Sept livrables : application web, import Excel, recherche multicritère, recherche DNS, gestion des utilisateurs, export et sauvegarde. Mise en production le 20 août 2026 sur Docker, Jenkins et Kubernetes.</a:t>
+              <a:t>Cadrage, développement et tests sont conformes au prévisionnel. L’écart d’environ un mois vient d’une seule cause : le volume de cas particuliers découverts pendant les tests, qui a ajouté une étape de traitement et décalé la stabilisation.</a:t>
             </a:r>
             <a:endParaRPr lang="en-US" dirty="0"/>
           </a:p>
@@ -1660,7 +1660,7 @@
           <a:p>
             <a:r>
               <a:rPr lang="en-US" dirty="0"/>
-              <a:t>Cas réel, identifiants masqués : une recherche d’adresse IP sur l’ensemble de la base retourne instantanément les deux fichiers concernés, avec la route correspondante. La recherche DNS enrichit les résultats.</a:t>
+              <a:t>Le premier imprévu a été limité par une demande d’accès anticipée. Le second m’a conduit à généraliser le moteur d’import plutôt que traiter les fichiers un par un : c’est ce choix qui explique le mois de retard, validé avec mon maître d’apprentissage.</a:t>
             </a:r>
             <a:endParaRPr lang="en-US" dirty="0"/>
           </a:p>
@@ -1748,7 +1748,7 @@
           <a:p>
             <a:r>
               <a:rPr lang="en-US" dirty="0"/>
-              <a:t>Cadrage, développement et tests sont conformes au prévisionnel. L’écart d’environ un mois vient d’une seule cause : le volume de cas particuliers découverts pendant les tests, qui a ajouté une étape de traitement et décalé la stabilisation.</a:t>
+              <a:t>Sept livrables : application web, import Excel, recherche multicritère, recherche DNS, gestion des utilisateurs, export et sauvegarde. Mise en production le 20 août 2026 sur Docker, Jenkins et Kubernetes.</a:t>
             </a:r>
             <a:endParaRPr lang="en-US" dirty="0"/>
           </a:p>
@@ -2693,7 +2693,7 @@
           <p:nvPr/>
         </p:nvSpPr>
         <p:spPr>
-          <a:xfrm>
+          <a:xfrm rot="-900000">
             <a:off x="10922000" y="254000"/>
             <a:ext cx="457200" cy="457200"/>
           </a:xfrm>
@@ -2757,7 +2757,7 @@
                 <a:ea typeface="JetBrains Mono" pitchFamily="34" charset="-122"/>
                 <a:cs typeface="JetBrains Mono" pitchFamily="34" charset="-120"/>
               </a:rPr>
-              <a:t>10 / 15 — DÉMARCHE</a:t>
+              <a:t>10 / 15 — RÉSULTATS</a:t>
             </a:r>
             <a:endParaRPr lang="en-US" sz="1200" dirty="0"/>
           </a:p>
@@ -2879,7 +2879,7 @@
                 <a:ea typeface="Space Grotesk" pitchFamily="34" charset="-122"/>
                 <a:cs typeface="Space Grotesk" pitchFamily="34" charset="-120"/>
               </a:rPr>
-              <a:t>Deux imprévus, un arbitrage</a:t>
+              <a:t>Une recherche IP en quelques secondes</a:t>
             </a:r>
             <a:endParaRPr lang="en-US" sz="3600" dirty="0"/>
           </a:p>
@@ -2894,7 +2894,7 @@
         <p:spPr>
           <a:xfrm>
             <a:off x="812800" y="1587500"/>
-            <a:ext cx="5156200" cy="2540000"/>
+            <a:ext cx="5130800" cy="3371850"/>
           </a:xfrm>
           <a:prstGeom prst="rect">
             <a:avLst/>
@@ -2917,136 +2917,40 @@
           </a:effectLst>
         </p:spPr>
       </p:sp>
-      <p:sp>
-        <p:nvSpPr>
-          <p:cNvPr id="12" name="Text 7"/>
-          <p:cNvSpPr txBox="1"/>
-          <p:nvPr/>
-        </p:nvSpPr>
-        <p:spPr>
-          <a:xfrm>
-            <a:off x="1041400" y="1816100"/>
-            <a:ext cx="3810000" cy="215900"/>
-          </a:xfrm>
-          <a:prstGeom prst="rect">
-            <a:avLst/>
-          </a:prstGeom>
-          <a:noFill/>
-          <a:ln/>
-        </p:spPr>
-        <p:txBody>
-          <a:bodyPr wrap="square" lIns="0" tIns="0" rIns="0" bIns="0" rtlCol="0" anchor="t"/>
-          <a:lstStyle/>
-          <a:p>
-            <a:pPr indent="0" marL="0">
-              <a:buNone/>
-            </a:pPr>
-            <a:r>
-              <a:rPr lang="en-US" sz="1200" b="1" spc="200" kern="0" dirty="0">
-                <a:solidFill>
-                  <a:srgbClr val="0B4F7A"/>
-                </a:solidFill>
-                <a:latin typeface="JetBrains Mono" pitchFamily="34" charset="0"/>
-                <a:ea typeface="JetBrains Mono" pitchFamily="34" charset="-122"/>
-                <a:cs typeface="JetBrains Mono" pitchFamily="34" charset="-120"/>
-              </a:rPr>
-              <a:t>IMPRÉVU 01</a:t>
-            </a:r>
-            <a:endParaRPr lang="en-US" sz="1200" dirty="0"/>
-          </a:p>
-        </p:txBody>
-      </p:sp>
-      <p:sp>
-        <p:nvSpPr>
-          <p:cNvPr id="13" name="Text 8"/>
-          <p:cNvSpPr txBox="1"/>
-          <p:nvPr/>
-        </p:nvSpPr>
-        <p:spPr>
-          <a:xfrm>
-            <a:off x="1041400" y="2133600"/>
-            <a:ext cx="4699000" cy="355600"/>
-          </a:xfrm>
-          <a:prstGeom prst="rect">
-            <a:avLst/>
-          </a:prstGeom>
-          <a:noFill/>
-          <a:ln/>
-        </p:spPr>
-        <p:txBody>
-          <a:bodyPr wrap="square" lIns="0" tIns="0" rIns="0" bIns="0" rtlCol="0" anchor="t"/>
-          <a:lstStyle/>
-          <a:p>
-            <a:pPr indent="0" marL="0">
-              <a:buNone/>
-            </a:pPr>
-            <a:r>
-              <a:rPr lang="en-US" sz="2000" b="1" dirty="0">
-                <a:solidFill>
-                  <a:srgbClr val="16181D"/>
-                </a:solidFill>
-                <a:latin typeface="Space Grotesk" pitchFamily="34" charset="0"/>
-                <a:ea typeface="Space Grotesk" pitchFamily="34" charset="-122"/>
-                <a:cs typeface="Space Grotesk" pitchFamily="34" charset="-120"/>
-              </a:rPr>
-              <a:t>Accès et droits</a:t>
-            </a:r>
-            <a:endParaRPr lang="en-US" sz="2000" dirty="0"/>
-          </a:p>
-        </p:txBody>
-      </p:sp>
-      <p:sp>
-        <p:nvSpPr>
-          <p:cNvPr id="14" name="Text 9"/>
-          <p:cNvSpPr txBox="1"/>
-          <p:nvPr/>
-        </p:nvSpPr>
-        <p:spPr>
-          <a:xfrm>
-            <a:off x="1041400" y="2667000"/>
-            <a:ext cx="4699000" cy="1270000"/>
-          </a:xfrm>
-          <a:prstGeom prst="rect">
-            <a:avLst/>
-          </a:prstGeom>
-          <a:noFill/>
-          <a:ln/>
-        </p:spPr>
-        <p:txBody>
-          <a:bodyPr wrap="square" lIns="0" tIns="0" rIns="0" bIns="0" rtlCol="0" anchor="t"/>
-          <a:lstStyle/>
-          <a:p>
-            <a:pPr indent="0" marL="0">
-              <a:lnSpc>
-                <a:spcPct val="105000"/>
-              </a:lnSpc>
-              <a:buNone/>
-            </a:pPr>
-            <a:r>
-              <a:rPr lang="en-US" sz="1600" dirty="0">
-                <a:solidFill>
-                  <a:srgbClr val="16181D"/>
-                </a:solidFill>
-                <a:latin typeface="IBM Plex Sans" pitchFamily="34" charset="0"/>
-                <a:ea typeface="IBM Plex Sans" pitchFamily="34" charset="-122"/>
-                <a:cs typeface="IBM Plex Sans" pitchFamily="34" charset="-120"/>
-              </a:rPr>
-              <a:t>Autorisations nécessaires avant de pouvoir développer et tester. Demande anticipée dès mars 2026.</a:t>
-            </a:r>
-            <a:endParaRPr lang="en-US" sz="1600" dirty="0"/>
-          </a:p>
-        </p:txBody>
-      </p:sp>
-      <p:sp>
-        <p:nvSpPr>
-          <p:cNvPr id="15" name="Shape 10"/>
+      <p:pic>
+        <p:nvPicPr>
+          <p:cNvPr id="12" name="Image 2" descr="Recherche multicritère par IP : 2 fichiers trouvés avec le détail de la route">    </p:cNvPr>
+          <p:cNvPicPr>
+            <a:picLocks noChangeAspect="1"/>
+          </p:cNvPicPr>
+          <p:nvPr/>
+        </p:nvPicPr>
+        <p:blipFill>
+          <a:blip r:embed="rId3"/>
+          <a:stretch>
+            <a:fillRect/>
+          </a:stretch>
+        </p:blipFill>
+        <p:spPr>
+          <a:xfrm>
+            <a:off x="838200" y="1612900"/>
+            <a:ext cx="5080000" cy="3321050"/>
+          </a:xfrm>
+          <a:prstGeom prst="rect">
+            <a:avLst/>
+          </a:prstGeom>
+        </p:spPr>
+      </p:pic>
+      <p:sp>
+        <p:nvSpPr>
+          <p:cNvPr id="13" name="Shape 7"/>
           <p:cNvSpPr/>
           <p:nvPr/>
         </p:nvSpPr>
         <p:spPr>
           <a:xfrm>
-            <a:off x="6223000" y="1587500"/>
-            <a:ext cx="5156200" cy="2540000"/>
+            <a:off x="6248400" y="1587500"/>
+            <a:ext cx="5130800" cy="3371850"/>
           </a:xfrm>
           <a:prstGeom prst="rect">
             <a:avLst/>
@@ -3069,16 +2973,40 @@
           </a:effectLst>
         </p:spPr>
       </p:sp>
-      <p:sp>
-        <p:nvSpPr>
-          <p:cNvPr id="16" name="Text 11"/>
+      <p:pic>
+        <p:nvPicPr>
+          <p:cNvPr id="14" name="Image 3" descr="Recherche DNS : adresse IPv4 et alias CNAME">    </p:cNvPr>
+          <p:cNvPicPr>
+            <a:picLocks noChangeAspect="1"/>
+          </p:cNvPicPr>
+          <p:nvPr/>
+        </p:nvPicPr>
+        <p:blipFill>
+          <a:blip r:embed="rId4"/>
+          <a:stretch>
+            <a:fillRect/>
+          </a:stretch>
+        </p:blipFill>
+        <p:spPr>
+          <a:xfrm>
+            <a:off x="6273800" y="1612900"/>
+            <a:ext cx="5080000" cy="3321050"/>
+          </a:xfrm>
+          <a:prstGeom prst="rect">
+            <a:avLst/>
+          </a:prstGeom>
+        </p:spPr>
+      </p:pic>
+      <p:sp>
+        <p:nvSpPr>
+          <p:cNvPr id="15" name="Text 8"/>
           <p:cNvSpPr txBox="1"/>
           <p:nvPr/>
         </p:nvSpPr>
         <p:spPr>
           <a:xfrm>
-            <a:off x="6451600" y="1816100"/>
-            <a:ext cx="3810000" cy="215900"/>
+            <a:off x="812800" y="5143500"/>
+            <a:ext cx="5130800" cy="571500"/>
           </a:xfrm>
           <a:prstGeom prst="rect">
             <a:avLst/>
@@ -3094,88 +3022,7 @@
               <a:buNone/>
             </a:pPr>
             <a:r>
-              <a:rPr lang="en-US" sz="1200" b="1" spc="200" kern="0" dirty="0">
-                <a:solidFill>
-                  <a:srgbClr val="0B4F7A"/>
-                </a:solidFill>
-                <a:latin typeface="JetBrains Mono" pitchFamily="34" charset="0"/>
-                <a:ea typeface="JetBrains Mono" pitchFamily="34" charset="-122"/>
-                <a:cs typeface="JetBrains Mono" pitchFamily="34" charset="-120"/>
-              </a:rPr>
-              <a:t>IMPRÉVU 02</a:t>
-            </a:r>
-            <a:endParaRPr lang="en-US" sz="1200" dirty="0"/>
-          </a:p>
-        </p:txBody>
-      </p:sp>
-      <p:sp>
-        <p:nvSpPr>
-          <p:cNvPr id="17" name="Text 12"/>
-          <p:cNvSpPr txBox="1"/>
-          <p:nvPr/>
-        </p:nvSpPr>
-        <p:spPr>
-          <a:xfrm>
-            <a:off x="6451600" y="2133600"/>
-            <a:ext cx="4699000" cy="355600"/>
-          </a:xfrm>
-          <a:prstGeom prst="rect">
-            <a:avLst/>
-          </a:prstGeom>
-          <a:noFill/>
-          <a:ln/>
-        </p:spPr>
-        <p:txBody>
-          <a:bodyPr wrap="square" lIns="0" tIns="0" rIns="0" bIns="0" rtlCol="0" anchor="t"/>
-          <a:lstStyle/>
-          <a:p>
-            <a:pPr indent="0" marL="0">
-              <a:buNone/>
-            </a:pPr>
-            <a:r>
-              <a:rPr lang="en-US" sz="2000" b="1" dirty="0">
-                <a:solidFill>
-                  <a:srgbClr val="16181D"/>
-                </a:solidFill>
-                <a:latin typeface="Space Grotesk" pitchFamily="34" charset="0"/>
-                <a:ea typeface="Space Grotesk" pitchFamily="34" charset="-122"/>
-                <a:cs typeface="Space Grotesk" pitchFamily="34" charset="-120"/>
-              </a:rPr>
-              <a:t>Fichiers hétérogènes</a:t>
-            </a:r>
-            <a:endParaRPr lang="en-US" sz="2000" dirty="0"/>
-          </a:p>
-        </p:txBody>
-      </p:sp>
-      <p:sp>
-        <p:nvSpPr>
-          <p:cNvPr id="18" name="Text 13"/>
-          <p:cNvSpPr txBox="1"/>
-          <p:nvPr/>
-        </p:nvSpPr>
-        <p:spPr>
-          <a:xfrm>
-            <a:off x="6451600" y="2667000"/>
-            <a:ext cx="4699000" cy="1270000"/>
-          </a:xfrm>
-          <a:prstGeom prst="rect">
-            <a:avLst/>
-          </a:prstGeom>
-          <a:noFill/>
-          <a:ln/>
-        </p:spPr>
-        <p:txBody>
-          <a:bodyPr wrap="square" lIns="0" tIns="0" rIns="0" bIns="0" rtlCol="0" anchor="t"/>
-          <a:lstStyle/>
-          <a:p>
-            <a:pPr indent="0" marL="0">
-              <a:lnSpc>
-                <a:spcPct val="105000"/>
-              </a:lnSpc>
-              <a:buNone/>
-            </a:pPr>
-            <a:r>
-              <a:rPr lang="en-US" sz="1600" dirty="0">
+              <a:rPr lang="en-US" sz="1400" dirty="0">
                 <a:solidFill>
                   <a:srgbClr val="16181D"/>
                 </a:solidFill>
@@ -3183,42 +3030,22 @@
                 <a:ea typeface="IBM Plex Sans" pitchFamily="34" charset="-122"/>
                 <a:cs typeface="IBM Plex Sans" pitchFamily="34" charset="-120"/>
               </a:rPr>
-              <a:t>Structures variées, jusqu’à 2003. Une vingtaine de fichiers particuliers identifiés en test.</a:t>
+              <a:t>Recherche multicritère : 2 fichiers sur 2 432 matrices, route détaillée</a:t>
             </a:r>
-            <a:endParaRPr lang="en-US" sz="1600" dirty="0"/>
+            <a:endParaRPr lang="en-US" sz="1400" dirty="0"/>
           </a:p>
         </p:txBody>
       </p:sp>
       <p:sp>
         <p:nvSpPr>
-          <p:cNvPr id="19" name="Shape 14"/>
-          <p:cNvSpPr/>
-          <p:nvPr/>
-        </p:nvSpPr>
-        <p:spPr>
-          <a:xfrm>
-            <a:off x="812800" y="4572000"/>
-            <a:ext cx="10566400" cy="1016000"/>
-          </a:xfrm>
-          <a:prstGeom prst="rect">
-            <a:avLst/>
-          </a:prstGeom>
-          <a:solidFill>
-            <a:srgbClr val="16181D"/>
-          </a:solidFill>
-          <a:ln/>
-        </p:spPr>
-      </p:sp>
-      <p:sp>
-        <p:nvSpPr>
-          <p:cNvPr id="20" name="Text 15"/>
+          <p:cNvPr id="16" name="Text 9"/>
           <p:cNvSpPr txBox="1"/>
           <p:nvPr/>
         </p:nvSpPr>
         <p:spPr>
           <a:xfrm>
-            <a:off x="1066800" y="4572000"/>
-            <a:ext cx="10058400" cy="1016000"/>
+            <a:off x="6248400" y="5143500"/>
+            <a:ext cx="5130800" cy="571500"/>
           </a:xfrm>
           <a:prstGeom prst="rect">
             <a:avLst/>
@@ -3227,24 +3054,24 @@
           <a:ln/>
         </p:spPr>
         <p:txBody>
-          <a:bodyPr wrap="square" lIns="0" tIns="0" rIns="0" bIns="0" rtlCol="0" anchor="ctr"/>
+          <a:bodyPr wrap="square" lIns="0" tIns="0" rIns="0" bIns="0" rtlCol="0" anchor="t"/>
           <a:lstStyle/>
           <a:p>
             <a:pPr indent="0" marL="0">
               <a:buNone/>
             </a:pPr>
             <a:r>
-              <a:rPr lang="en-US" sz="2000" b="1" dirty="0">
+              <a:rPr lang="en-US" sz="1400" dirty="0">
                 <a:solidFill>
-                  <a:srgbClr val="F3F0E8"/>
+                  <a:srgbClr val="16181D"/>
                 </a:solidFill>
-                <a:latin typeface="Space Grotesk" pitchFamily="34" charset="0"/>
-                <a:ea typeface="Space Grotesk" pitchFamily="34" charset="-122"/>
-                <a:cs typeface="Space Grotesk" pitchFamily="34" charset="-120"/>
+                <a:latin typeface="IBM Plex Sans" pitchFamily="34" charset="0"/>
+                <a:ea typeface="IBM Plex Sans" pitchFamily="34" charset="-122"/>
+                <a:cs typeface="IBM Plex Sans" pitchFamily="34" charset="-120"/>
               </a:rPr>
-              <a:t>Arbitrage : privilégier la robustesse du moteur d’import plutôt que le calendrier initial.</a:t>
+              <a:t>Recherche DNS : enrichissement des résultats</a:t>
             </a:r>
-            <a:endParaRPr lang="en-US" sz="2000" dirty="0"/>
+            <a:endParaRPr lang="en-US" sz="1400" dirty="0"/>
           </a:p>
         </p:txBody>
       </p:sp>
@@ -14672,7 +14499,7 @@
           <p:nvPr/>
         </p:nvSpPr>
         <p:spPr>
-          <a:xfrm>
+          <a:xfrm rot="900000">
             <a:off x="10922000" y="254000"/>
             <a:ext cx="457200" cy="457200"/>
           </a:xfrm>
@@ -14736,7 +14563,7 @@
                 <a:ea typeface="JetBrains Mono" pitchFamily="34" charset="-122"/>
                 <a:cs typeface="JetBrains Mono" pitchFamily="34" charset="-120"/>
               </a:rPr>
-              <a:t>07 / 15 — RÉSULTATS</a:t>
+              <a:t>07 / 15 — DÉMARCHE</a:t>
             </a:r>
             <a:endParaRPr lang="en-US" sz="1200" dirty="0"/>
           </a:p>
@@ -14858,7 +14685,7 @@
                 <a:ea typeface="Space Grotesk" pitchFamily="34" charset="-122"/>
                 <a:cs typeface="Space Grotesk" pitchFamily="34" charset="-120"/>
               </a:rPr>
-              <a:t>RIPTIS en production le 20 août 2026</a:t>
+              <a:t>Un mois de décalage en fin de projet</a:t>
             </a:r>
             <a:endParaRPr lang="en-US" sz="3600" dirty="0"/>
           </a:p>
@@ -14873,7 +14700,7 @@
         <p:spPr>
           <a:xfrm>
             <a:off x="812800" y="1587500"/>
-            <a:ext cx="6096000" cy="4044950"/>
+            <a:ext cx="6985000" cy="3625850"/>
           </a:xfrm>
           <a:prstGeom prst="rect">
             <a:avLst/>
@@ -14898,7 +14725,7 @@
       </p:sp>
       <p:pic>
         <p:nvPicPr>
-          <p:cNvPr id="12" name="Image 2" descr="Tableau de bord d’accueil de RIPTIS : 2 432 matrices centralisées">    </p:cNvPr>
+          <p:cNvPr id="12" name="Image 2" descr="Planning prévisionnel et réalisé sur la même échelle de temps">    </p:cNvPr>
           <p:cNvPicPr>
             <a:picLocks noChangeAspect="1"/>
           </p:cNvPicPr>
@@ -14913,7 +14740,7 @@
         <p:spPr>
           <a:xfrm>
             <a:off x="838200" y="1612900"/>
-            <a:ext cx="6045200" cy="3994150"/>
+            <a:ext cx="6934200" cy="3575050"/>
           </a:xfrm>
           <a:prstGeom prst="rect">
             <a:avLst/>
@@ -14922,14 +14749,85 @@
       </p:pic>
       <p:sp>
         <p:nvSpPr>
-          <p:cNvPr id="13" name="Text 7"/>
+          <p:cNvPr id="13" name="Shape 7"/>
+          <p:cNvSpPr/>
+          <p:nvPr/>
+        </p:nvSpPr>
+        <p:spPr>
+          <a:xfrm>
+            <a:off x="8102600" y="1587500"/>
+            <a:ext cx="3276600" cy="1397000"/>
+          </a:xfrm>
+          <a:prstGeom prst="rect">
+            <a:avLst/>
+          </a:prstGeom>
+          <a:solidFill>
+            <a:srgbClr val="FBF9F3"/>
+          </a:solidFill>
+          <a:ln w="25400">
+            <a:solidFill>
+              <a:srgbClr val="16181D"/>
+            </a:solidFill>
+            <a:prstDash val="solid"/>
+          </a:ln>
+          <a:effectLst>
+            <a:outerShdw sx="100000" sy="100000" kx="0" ky="0" algn="bl" rotWithShape="0" blurRad="101600" dist="63500" dir="2700000">
+              <a:srgbClr val="16181D">
+                <a:alpha val="100000"/>
+              </a:srgbClr>
+            </a:outerShdw>
+          </a:effectLst>
+        </p:spPr>
+      </p:sp>
+      <p:sp>
+        <p:nvSpPr>
+          <p:cNvPr id="14" name="Text 8"/>
           <p:cNvSpPr txBox="1"/>
           <p:nvPr/>
         </p:nvSpPr>
         <p:spPr>
           <a:xfrm>
-            <a:off x="7213600" y="1587500"/>
-            <a:ext cx="4165600" cy="355600"/>
+            <a:off x="8331200" y="1841500"/>
+            <a:ext cx="2794000" cy="215900"/>
+          </a:xfrm>
+          <a:prstGeom prst="rect">
+            <a:avLst/>
+          </a:prstGeom>
+          <a:noFill/>
+          <a:ln/>
+        </p:spPr>
+        <p:txBody>
+          <a:bodyPr wrap="square" lIns="0" tIns="0" rIns="0" bIns="0" rtlCol="0" anchor="t"/>
+          <a:lstStyle/>
+          <a:p>
+            <a:pPr indent="0" marL="0">
+              <a:buNone/>
+            </a:pPr>
+            <a:r>
+              <a:rPr lang="en-US" sz="1200" b="1" spc="200" kern="0" dirty="0">
+                <a:solidFill>
+                  <a:srgbClr val="0B4F7A"/>
+                </a:solidFill>
+                <a:latin typeface="JetBrains Mono" pitchFamily="34" charset="0"/>
+                <a:ea typeface="JetBrains Mono" pitchFamily="34" charset="-122"/>
+                <a:cs typeface="JetBrains Mono" pitchFamily="34" charset="-120"/>
+              </a:rPr>
+              <a:t>PRÉVU</a:t>
+            </a:r>
+            <a:endParaRPr lang="en-US" sz="1200" dirty="0"/>
+          </a:p>
+        </p:txBody>
+      </p:sp>
+      <p:sp>
+        <p:nvSpPr>
+          <p:cNvPr id="15" name="Text 9"/>
+          <p:cNvSpPr txBox="1"/>
+          <p:nvPr/>
+        </p:nvSpPr>
+        <p:spPr>
+          <a:xfrm>
+            <a:off x="8331200" y="2222500"/>
+            <a:ext cx="2794000" cy="406400"/>
           </a:xfrm>
           <a:prstGeom prst="rect">
             <a:avLst/>
@@ -14947,13 +14845,13 @@
             <a:r>
               <a:rPr lang="en-US" sz="2000" b="1" dirty="0">
                 <a:solidFill>
-                  <a:srgbClr val="0B4F7A"/>
+                  <a:srgbClr val="16181D"/>
                 </a:solidFill>
                 <a:latin typeface="Space Grotesk" pitchFamily="34" charset="0"/>
                 <a:ea typeface="Space Grotesk" pitchFamily="34" charset="-122"/>
                 <a:cs typeface="Space Grotesk" pitchFamily="34" charset="-120"/>
               </a:rPr>
-              <a:t>2 432 matrices</a:t>
+              <a:t>Juillet 2026</a:t>
             </a:r>
             <a:endParaRPr lang="en-US" sz="2000" dirty="0"/>
           </a:p>
@@ -14961,14 +14859,46 @@
       </p:sp>
       <p:sp>
         <p:nvSpPr>
-          <p:cNvPr id="14" name="Text 8"/>
+          <p:cNvPr id="16" name="Shape 10"/>
+          <p:cNvSpPr/>
+          <p:nvPr/>
+        </p:nvSpPr>
+        <p:spPr>
+          <a:xfrm>
+            <a:off x="8102600" y="3136900"/>
+            <a:ext cx="3276600" cy="1397000"/>
+          </a:xfrm>
+          <a:prstGeom prst="rect">
+            <a:avLst/>
+          </a:prstGeom>
+          <a:solidFill>
+            <a:srgbClr val="FBF9F3"/>
+          </a:solidFill>
+          <a:ln w="25400">
+            <a:solidFill>
+              <a:srgbClr val="16181D"/>
+            </a:solidFill>
+            <a:prstDash val="solid"/>
+          </a:ln>
+          <a:effectLst>
+            <a:outerShdw sx="100000" sy="100000" kx="0" ky="0" algn="bl" rotWithShape="0" blurRad="101600" dist="63500" dir="2700000">
+              <a:srgbClr val="16181D">
+                <a:alpha val="100000"/>
+              </a:srgbClr>
+            </a:outerShdw>
+          </a:effectLst>
+        </p:spPr>
+      </p:sp>
+      <p:sp>
+        <p:nvSpPr>
+          <p:cNvPr id="17" name="Text 11"/>
           <p:cNvSpPr txBox="1"/>
           <p:nvPr/>
         </p:nvSpPr>
         <p:spPr>
           <a:xfrm>
-            <a:off x="7213600" y="2159000"/>
-            <a:ext cx="4165600" cy="2667000"/>
+            <a:off x="8331200" y="3390900"/>
+            <a:ext cx="2794000" cy="215900"/>
           </a:xfrm>
           <a:prstGeom prst="rect">
             <a:avLst/>
@@ -14980,130 +14910,60 @@
           <a:bodyPr wrap="square" lIns="0" tIns="0" rIns="0" bIns="0" rtlCol="0" anchor="t"/>
           <a:lstStyle/>
           <a:p>
-            <a:pPr marL="279400" indent="-279400">
-              <a:spcAft>
-                <a:spcPts val="800"/>
-              </a:spcAft>
-              <a:buSzPct val="100000"/>
-              <a:buChar char="•"/>
+            <a:pPr indent="0" marL="0">
+              <a:buNone/>
             </a:pPr>
             <a:r>
-              <a:rPr lang="en-US" sz="1600" dirty="0">
+              <a:rPr lang="en-US" sz="1200" b="1" spc="200" kern="0" dirty="0">
+                <a:solidFill>
+                  <a:srgbClr val="0B4F7A"/>
+                </a:solidFill>
+                <a:latin typeface="JetBrains Mono" pitchFamily="34" charset="0"/>
+                <a:ea typeface="JetBrains Mono" pitchFamily="34" charset="-122"/>
+                <a:cs typeface="JetBrains Mono" pitchFamily="34" charset="-120"/>
+              </a:rPr>
+              <a:t>RÉALISÉ</a:t>
+            </a:r>
+            <a:endParaRPr lang="en-US" sz="1200" dirty="0"/>
+          </a:p>
+        </p:txBody>
+      </p:sp>
+      <p:sp>
+        <p:nvSpPr>
+          <p:cNvPr id="18" name="Text 12"/>
+          <p:cNvSpPr txBox="1"/>
+          <p:nvPr/>
+        </p:nvSpPr>
+        <p:spPr>
+          <a:xfrm>
+            <a:off x="8331200" y="3771900"/>
+            <a:ext cx="2794000" cy="406400"/>
+          </a:xfrm>
+          <a:prstGeom prst="rect">
+            <a:avLst/>
+          </a:prstGeom>
+          <a:noFill/>
+          <a:ln/>
+        </p:spPr>
+        <p:txBody>
+          <a:bodyPr wrap="square" lIns="0" tIns="0" rIns="0" bIns="0" rtlCol="0" anchor="t"/>
+          <a:lstStyle/>
+          <a:p>
+            <a:pPr indent="0" marL="0">
+              <a:buNone/>
+            </a:pPr>
+            <a:r>
+              <a:rPr lang="en-US" sz="2000" b="1" dirty="0">
                 <a:solidFill>
                   <a:srgbClr val="16181D"/>
                 </a:solidFill>
-                <a:latin typeface="IBM Plex Sans" pitchFamily="34" charset="0"/>
-                <a:ea typeface="IBM Plex Sans" pitchFamily="34" charset="-122"/>
-                <a:cs typeface="IBM Plex Sans" pitchFamily="34" charset="-120"/>
+                <a:latin typeface="Space Grotesk" pitchFamily="34" charset="0"/>
+                <a:ea typeface="Space Grotesk" pitchFamily="34" charset="-122"/>
+                <a:cs typeface="Space Grotesk" pitchFamily="34" charset="-120"/>
               </a:rPr>
-              <a:t>Import Excel multi-formats</a:t>
+              <a:t>20 août 2026</a:t>
             </a:r>
-            <a:endParaRPr lang="en-US" sz="1600" dirty="0"/>
-          </a:p>
-          <a:p>
-            <a:pPr marL="279400" indent="-279400">
-              <a:spcAft>
-                <a:spcPts val="800"/>
-              </a:spcAft>
-              <a:buSzPct val="100000"/>
-              <a:buChar char="•"/>
-            </a:pPr>
-            <a:r>
-              <a:rPr lang="en-US" sz="1600" dirty="0">
-                <a:solidFill>
-                  <a:srgbClr val="16181D"/>
-                </a:solidFill>
-                <a:latin typeface="IBM Plex Sans" pitchFamily="34" charset="0"/>
-                <a:ea typeface="IBM Plex Sans" pitchFamily="34" charset="-122"/>
-                <a:cs typeface="IBM Plex Sans" pitchFamily="34" charset="-120"/>
-              </a:rPr>
-              <a:t>Recherche multicritère</a:t>
-            </a:r>
-            <a:endParaRPr lang="en-US" sz="1600" dirty="0"/>
-          </a:p>
-          <a:p>
-            <a:pPr marL="279400" indent="-279400">
-              <a:spcAft>
-                <a:spcPts val="800"/>
-              </a:spcAft>
-              <a:buSzPct val="100000"/>
-              <a:buChar char="•"/>
-            </a:pPr>
-            <a:r>
-              <a:rPr lang="en-US" sz="1600" dirty="0">
-                <a:solidFill>
-                  <a:srgbClr val="16181D"/>
-                </a:solidFill>
-                <a:latin typeface="IBM Plex Sans" pitchFamily="34" charset="0"/>
-                <a:ea typeface="IBM Plex Sans" pitchFamily="34" charset="-122"/>
-                <a:cs typeface="IBM Plex Sans" pitchFamily="34" charset="-120"/>
-              </a:rPr>
-              <a:t>Recherche DNS</a:t>
-            </a:r>
-            <a:endParaRPr lang="en-US" sz="1600" dirty="0"/>
-          </a:p>
-          <a:p>
-            <a:pPr marL="279400" indent="-279400">
-              <a:spcAft>
-                <a:spcPts val="800"/>
-              </a:spcAft>
-              <a:buSzPct val="100000"/>
-              <a:buChar char="•"/>
-            </a:pPr>
-            <a:r>
-              <a:rPr lang="en-US" sz="1600" dirty="0">
-                <a:solidFill>
-                  <a:srgbClr val="16181D"/>
-                </a:solidFill>
-                <a:latin typeface="IBM Plex Sans" pitchFamily="34" charset="0"/>
-                <a:ea typeface="IBM Plex Sans" pitchFamily="34" charset="-122"/>
-                <a:cs typeface="IBM Plex Sans" pitchFamily="34" charset="-120"/>
-              </a:rPr>
-              <a:t>Droits par OIDC</a:t>
-            </a:r>
-            <a:endParaRPr lang="en-US" sz="1600" dirty="0"/>
-          </a:p>
-          <a:p>
-            <a:pPr marL="279400" indent="-279400">
-              <a:spcAft>
-                <a:spcPts val="800"/>
-              </a:spcAft>
-              <a:buSzPct val="100000"/>
-              <a:buChar char="•"/>
-            </a:pPr>
-            <a:r>
-              <a:rPr lang="en-US" sz="1600" dirty="0">
-                <a:solidFill>
-                  <a:srgbClr val="16181D"/>
-                </a:solidFill>
-                <a:latin typeface="IBM Plex Sans" pitchFamily="34" charset="0"/>
-                <a:ea typeface="IBM Plex Sans" pitchFamily="34" charset="-122"/>
-                <a:cs typeface="IBM Plex Sans" pitchFamily="34" charset="-120"/>
-              </a:rPr>
-              <a:t>Export Excel</a:t>
-            </a:r>
-            <a:endParaRPr lang="en-US" sz="1600" dirty="0"/>
-          </a:p>
-          <a:p>
-            <a:pPr marL="279400" indent="-279400">
-              <a:spcAft>
-                <a:spcPts val="800"/>
-              </a:spcAft>
-              <a:buSzPct val="100000"/>
-              <a:buChar char="•"/>
-            </a:pPr>
-            <a:r>
-              <a:rPr lang="en-US" sz="1600" dirty="0">
-                <a:solidFill>
-                  <a:srgbClr val="16181D"/>
-                </a:solidFill>
-                <a:latin typeface="IBM Plex Sans" pitchFamily="34" charset="0"/>
-                <a:ea typeface="IBM Plex Sans" pitchFamily="34" charset="-122"/>
-                <a:cs typeface="IBM Plex Sans" pitchFamily="34" charset="-120"/>
-              </a:rPr>
-              <a:t>Sauvegarde PostgreSQL</a:t>
-            </a:r>
-            <a:endParaRPr lang="en-US" sz="1600" dirty="0"/>
+            <a:endParaRPr lang="en-US" sz="2000" dirty="0"/>
           </a:p>
         </p:txBody>
       </p:sp>
@@ -15208,7 +15068,7 @@
           <p:nvPr/>
         </p:nvSpPr>
         <p:spPr>
-          <a:xfrm rot="-900000">
+          <a:xfrm>
             <a:off x="10922000" y="254000"/>
             <a:ext cx="457200" cy="457200"/>
           </a:xfrm>
@@ -15272,7 +15132,7 @@
                 <a:ea typeface="JetBrains Mono" pitchFamily="34" charset="-122"/>
                 <a:cs typeface="JetBrains Mono" pitchFamily="34" charset="-120"/>
               </a:rPr>
-              <a:t>08 / 15 — RÉSULTATS</a:t>
+              <a:t>08 / 15 — DÉMARCHE</a:t>
             </a:r>
             <a:endParaRPr lang="en-US" sz="1200" dirty="0"/>
           </a:p>
@@ -15394,7 +15254,7 @@
                 <a:ea typeface="Space Grotesk" pitchFamily="34" charset="-122"/>
                 <a:cs typeface="Space Grotesk" pitchFamily="34" charset="-120"/>
               </a:rPr>
-              <a:t>Une recherche IP en quelques secondes</a:t>
+              <a:t>Deux imprévus, un arbitrage</a:t>
             </a:r>
             <a:endParaRPr lang="en-US" sz="3600" dirty="0"/>
           </a:p>
@@ -15409,7 +15269,7 @@
         <p:spPr>
           <a:xfrm>
             <a:off x="812800" y="1587500"/>
-            <a:ext cx="5130800" cy="3371850"/>
+            <a:ext cx="5156200" cy="2540000"/>
           </a:xfrm>
           <a:prstGeom prst="rect">
             <a:avLst/>
@@ -15432,40 +15292,136 @@
           </a:effectLst>
         </p:spPr>
       </p:sp>
-      <p:pic>
-        <p:nvPicPr>
-          <p:cNvPr id="12" name="Image 2" descr="Recherche multicritère par IP : 2 fichiers trouvés avec le détail de la route">    </p:cNvPr>
-          <p:cNvPicPr>
-            <a:picLocks noChangeAspect="1"/>
-          </p:cNvPicPr>
-          <p:nvPr/>
-        </p:nvPicPr>
-        <p:blipFill>
-          <a:blip r:embed="rId3"/>
-          <a:stretch>
-            <a:fillRect/>
-          </a:stretch>
-        </p:blipFill>
-        <p:spPr>
-          <a:xfrm>
-            <a:off x="838200" y="1612900"/>
-            <a:ext cx="5080000" cy="3321050"/>
-          </a:xfrm>
-          <a:prstGeom prst="rect">
-            <a:avLst/>
-          </a:prstGeom>
-        </p:spPr>
-      </p:pic>
-      <p:sp>
-        <p:nvSpPr>
-          <p:cNvPr id="13" name="Shape 7"/>
+      <p:sp>
+        <p:nvSpPr>
+          <p:cNvPr id="12" name="Text 7"/>
+          <p:cNvSpPr txBox="1"/>
+          <p:nvPr/>
+        </p:nvSpPr>
+        <p:spPr>
+          <a:xfrm>
+            <a:off x="1041400" y="1816100"/>
+            <a:ext cx="3810000" cy="215900"/>
+          </a:xfrm>
+          <a:prstGeom prst="rect">
+            <a:avLst/>
+          </a:prstGeom>
+          <a:noFill/>
+          <a:ln/>
+        </p:spPr>
+        <p:txBody>
+          <a:bodyPr wrap="square" lIns="0" tIns="0" rIns="0" bIns="0" rtlCol="0" anchor="t"/>
+          <a:lstStyle/>
+          <a:p>
+            <a:pPr indent="0" marL="0">
+              <a:buNone/>
+            </a:pPr>
+            <a:r>
+              <a:rPr lang="en-US" sz="1200" b="1" spc="200" kern="0" dirty="0">
+                <a:solidFill>
+                  <a:srgbClr val="0B4F7A"/>
+                </a:solidFill>
+                <a:latin typeface="JetBrains Mono" pitchFamily="34" charset="0"/>
+                <a:ea typeface="JetBrains Mono" pitchFamily="34" charset="-122"/>
+                <a:cs typeface="JetBrains Mono" pitchFamily="34" charset="-120"/>
+              </a:rPr>
+              <a:t>IMPRÉVU 01</a:t>
+            </a:r>
+            <a:endParaRPr lang="en-US" sz="1200" dirty="0"/>
+          </a:p>
+        </p:txBody>
+      </p:sp>
+      <p:sp>
+        <p:nvSpPr>
+          <p:cNvPr id="13" name="Text 8"/>
+          <p:cNvSpPr txBox="1"/>
+          <p:nvPr/>
+        </p:nvSpPr>
+        <p:spPr>
+          <a:xfrm>
+            <a:off x="1041400" y="2133600"/>
+            <a:ext cx="4699000" cy="355600"/>
+          </a:xfrm>
+          <a:prstGeom prst="rect">
+            <a:avLst/>
+          </a:prstGeom>
+          <a:noFill/>
+          <a:ln/>
+        </p:spPr>
+        <p:txBody>
+          <a:bodyPr wrap="square" lIns="0" tIns="0" rIns="0" bIns="0" rtlCol="0" anchor="t"/>
+          <a:lstStyle/>
+          <a:p>
+            <a:pPr indent="0" marL="0">
+              <a:buNone/>
+            </a:pPr>
+            <a:r>
+              <a:rPr lang="en-US" sz="2000" b="1" dirty="0">
+                <a:solidFill>
+                  <a:srgbClr val="16181D"/>
+                </a:solidFill>
+                <a:latin typeface="Space Grotesk" pitchFamily="34" charset="0"/>
+                <a:ea typeface="Space Grotesk" pitchFamily="34" charset="-122"/>
+                <a:cs typeface="Space Grotesk" pitchFamily="34" charset="-120"/>
+              </a:rPr>
+              <a:t>Accès et droits</a:t>
+            </a:r>
+            <a:endParaRPr lang="en-US" sz="2000" dirty="0"/>
+          </a:p>
+        </p:txBody>
+      </p:sp>
+      <p:sp>
+        <p:nvSpPr>
+          <p:cNvPr id="14" name="Text 9"/>
+          <p:cNvSpPr txBox="1"/>
+          <p:nvPr/>
+        </p:nvSpPr>
+        <p:spPr>
+          <a:xfrm>
+            <a:off x="1041400" y="2667000"/>
+            <a:ext cx="4699000" cy="1270000"/>
+          </a:xfrm>
+          <a:prstGeom prst="rect">
+            <a:avLst/>
+          </a:prstGeom>
+          <a:noFill/>
+          <a:ln/>
+        </p:spPr>
+        <p:txBody>
+          <a:bodyPr wrap="square" lIns="0" tIns="0" rIns="0" bIns="0" rtlCol="0" anchor="t"/>
+          <a:lstStyle/>
+          <a:p>
+            <a:pPr indent="0" marL="0">
+              <a:lnSpc>
+                <a:spcPct val="105000"/>
+              </a:lnSpc>
+              <a:buNone/>
+            </a:pPr>
+            <a:r>
+              <a:rPr lang="en-US" sz="1600" dirty="0">
+                <a:solidFill>
+                  <a:srgbClr val="16181D"/>
+                </a:solidFill>
+                <a:latin typeface="IBM Plex Sans" pitchFamily="34" charset="0"/>
+                <a:ea typeface="IBM Plex Sans" pitchFamily="34" charset="-122"/>
+                <a:cs typeface="IBM Plex Sans" pitchFamily="34" charset="-120"/>
+              </a:rPr>
+              <a:t>Autorisations nécessaires avant de pouvoir développer et tester. Demande anticipée dès mars 2026.</a:t>
+            </a:r>
+            <a:endParaRPr lang="en-US" sz="1600" dirty="0"/>
+          </a:p>
+        </p:txBody>
+      </p:sp>
+      <p:sp>
+        <p:nvSpPr>
+          <p:cNvPr id="15" name="Shape 10"/>
           <p:cNvSpPr/>
           <p:nvPr/>
         </p:nvSpPr>
         <p:spPr>
           <a:xfrm>
-            <a:off x="6248400" y="1587500"/>
-            <a:ext cx="5130800" cy="3371850"/>
+            <a:off x="6223000" y="1587500"/>
+            <a:ext cx="5156200" cy="2540000"/>
           </a:xfrm>
           <a:prstGeom prst="rect">
             <a:avLst/>
@@ -15488,40 +15444,16 @@
           </a:effectLst>
         </p:spPr>
       </p:sp>
-      <p:pic>
-        <p:nvPicPr>
-          <p:cNvPr id="14" name="Image 3" descr="Recherche DNS : adresse IPv4 et alias CNAME">    </p:cNvPr>
-          <p:cNvPicPr>
-            <a:picLocks noChangeAspect="1"/>
-          </p:cNvPicPr>
-          <p:nvPr/>
-        </p:nvPicPr>
-        <p:blipFill>
-          <a:blip r:embed="rId4"/>
-          <a:stretch>
-            <a:fillRect/>
-          </a:stretch>
-        </p:blipFill>
-        <p:spPr>
-          <a:xfrm>
-            <a:off x="6273800" y="1612900"/>
-            <a:ext cx="5080000" cy="3321050"/>
-          </a:xfrm>
-          <a:prstGeom prst="rect">
-            <a:avLst/>
-          </a:prstGeom>
-        </p:spPr>
-      </p:pic>
-      <p:sp>
-        <p:nvSpPr>
-          <p:cNvPr id="15" name="Text 8"/>
+      <p:sp>
+        <p:nvSpPr>
+          <p:cNvPr id="16" name="Text 11"/>
           <p:cNvSpPr txBox="1"/>
           <p:nvPr/>
         </p:nvSpPr>
         <p:spPr>
           <a:xfrm>
-            <a:off x="812800" y="5143500"/>
-            <a:ext cx="5130800" cy="571500"/>
+            <a:off x="6451600" y="1816100"/>
+            <a:ext cx="3810000" cy="215900"/>
           </a:xfrm>
           <a:prstGeom prst="rect">
             <a:avLst/>
@@ -15537,7 +15469,88 @@
               <a:buNone/>
             </a:pPr>
             <a:r>
-              <a:rPr lang="en-US" sz="1400" dirty="0">
+              <a:rPr lang="en-US" sz="1200" b="1" spc="200" kern="0" dirty="0">
+                <a:solidFill>
+                  <a:srgbClr val="0B4F7A"/>
+                </a:solidFill>
+                <a:latin typeface="JetBrains Mono" pitchFamily="34" charset="0"/>
+                <a:ea typeface="JetBrains Mono" pitchFamily="34" charset="-122"/>
+                <a:cs typeface="JetBrains Mono" pitchFamily="34" charset="-120"/>
+              </a:rPr>
+              <a:t>IMPRÉVU 02</a:t>
+            </a:r>
+            <a:endParaRPr lang="en-US" sz="1200" dirty="0"/>
+          </a:p>
+        </p:txBody>
+      </p:sp>
+      <p:sp>
+        <p:nvSpPr>
+          <p:cNvPr id="17" name="Text 12"/>
+          <p:cNvSpPr txBox="1"/>
+          <p:nvPr/>
+        </p:nvSpPr>
+        <p:spPr>
+          <a:xfrm>
+            <a:off x="6451600" y="2133600"/>
+            <a:ext cx="4699000" cy="355600"/>
+          </a:xfrm>
+          <a:prstGeom prst="rect">
+            <a:avLst/>
+          </a:prstGeom>
+          <a:noFill/>
+          <a:ln/>
+        </p:spPr>
+        <p:txBody>
+          <a:bodyPr wrap="square" lIns="0" tIns="0" rIns="0" bIns="0" rtlCol="0" anchor="t"/>
+          <a:lstStyle/>
+          <a:p>
+            <a:pPr indent="0" marL="0">
+              <a:buNone/>
+            </a:pPr>
+            <a:r>
+              <a:rPr lang="en-US" sz="2000" b="1" dirty="0">
+                <a:solidFill>
+                  <a:srgbClr val="16181D"/>
+                </a:solidFill>
+                <a:latin typeface="Space Grotesk" pitchFamily="34" charset="0"/>
+                <a:ea typeface="Space Grotesk" pitchFamily="34" charset="-122"/>
+                <a:cs typeface="Space Grotesk" pitchFamily="34" charset="-120"/>
+              </a:rPr>
+              <a:t>Fichiers hétérogènes</a:t>
+            </a:r>
+            <a:endParaRPr lang="en-US" sz="2000" dirty="0"/>
+          </a:p>
+        </p:txBody>
+      </p:sp>
+      <p:sp>
+        <p:nvSpPr>
+          <p:cNvPr id="18" name="Text 13"/>
+          <p:cNvSpPr txBox="1"/>
+          <p:nvPr/>
+        </p:nvSpPr>
+        <p:spPr>
+          <a:xfrm>
+            <a:off x="6451600" y="2667000"/>
+            <a:ext cx="4699000" cy="1270000"/>
+          </a:xfrm>
+          <a:prstGeom prst="rect">
+            <a:avLst/>
+          </a:prstGeom>
+          <a:noFill/>
+          <a:ln/>
+        </p:spPr>
+        <p:txBody>
+          <a:bodyPr wrap="square" lIns="0" tIns="0" rIns="0" bIns="0" rtlCol="0" anchor="t"/>
+          <a:lstStyle/>
+          <a:p>
+            <a:pPr indent="0" marL="0">
+              <a:lnSpc>
+                <a:spcPct val="105000"/>
+              </a:lnSpc>
+              <a:buNone/>
+            </a:pPr>
+            <a:r>
+              <a:rPr lang="en-US" sz="1600" dirty="0">
                 <a:solidFill>
                   <a:srgbClr val="16181D"/>
                 </a:solidFill>
@@ -15545,22 +15558,42 @@
                 <a:ea typeface="IBM Plex Sans" pitchFamily="34" charset="-122"/>
                 <a:cs typeface="IBM Plex Sans" pitchFamily="34" charset="-120"/>
               </a:rPr>
-              <a:t>Recherche multicritère : 2 fichiers sur 2 432 matrices, route détaillée</a:t>
+              <a:t>Structures variées, jusqu’à 2003. Une vingtaine de fichiers particuliers identifiés en test.</a:t>
             </a:r>
-            <a:endParaRPr lang="en-US" sz="1400" dirty="0"/>
+            <a:endParaRPr lang="en-US" sz="1600" dirty="0"/>
           </a:p>
         </p:txBody>
       </p:sp>
       <p:sp>
         <p:nvSpPr>
-          <p:cNvPr id="16" name="Text 9"/>
+          <p:cNvPr id="19" name="Shape 14"/>
+          <p:cNvSpPr/>
+          <p:nvPr/>
+        </p:nvSpPr>
+        <p:spPr>
+          <a:xfrm>
+            <a:off x="812800" y="4572000"/>
+            <a:ext cx="10566400" cy="1016000"/>
+          </a:xfrm>
+          <a:prstGeom prst="rect">
+            <a:avLst/>
+          </a:prstGeom>
+          <a:solidFill>
+            <a:srgbClr val="16181D"/>
+          </a:solidFill>
+          <a:ln/>
+        </p:spPr>
+      </p:sp>
+      <p:sp>
+        <p:nvSpPr>
+          <p:cNvPr id="20" name="Text 15"/>
           <p:cNvSpPr txBox="1"/>
           <p:nvPr/>
         </p:nvSpPr>
         <p:spPr>
           <a:xfrm>
-            <a:off x="6248400" y="5143500"/>
-            <a:ext cx="5130800" cy="571500"/>
+            <a:off x="1066800" y="4572000"/>
+            <a:ext cx="10058400" cy="1016000"/>
           </a:xfrm>
           <a:prstGeom prst="rect">
             <a:avLst/>
@@ -15569,24 +15602,24 @@
           <a:ln/>
         </p:spPr>
         <p:txBody>
-          <a:bodyPr wrap="square" lIns="0" tIns="0" rIns="0" bIns="0" rtlCol="0" anchor="t"/>
+          <a:bodyPr wrap="square" lIns="0" tIns="0" rIns="0" bIns="0" rtlCol="0" anchor="ctr"/>
           <a:lstStyle/>
           <a:p>
             <a:pPr indent="0" marL="0">
               <a:buNone/>
             </a:pPr>
             <a:r>
-              <a:rPr lang="en-US" sz="1400" dirty="0">
+              <a:rPr lang="en-US" sz="2000" b="1" dirty="0">
                 <a:solidFill>
-                  <a:srgbClr val="16181D"/>
+                  <a:srgbClr val="F3F0E8"/>
                 </a:solidFill>
-                <a:latin typeface="IBM Plex Sans" pitchFamily="34" charset="0"/>
-                <a:ea typeface="IBM Plex Sans" pitchFamily="34" charset="-122"/>
-                <a:cs typeface="IBM Plex Sans" pitchFamily="34" charset="-120"/>
+                <a:latin typeface="Space Grotesk" pitchFamily="34" charset="0"/>
+                <a:ea typeface="Space Grotesk" pitchFamily="34" charset="-122"/>
+                <a:cs typeface="Space Grotesk" pitchFamily="34" charset="-120"/>
               </a:rPr>
-              <a:t>Recherche DNS : enrichissement des résultats</a:t>
+              <a:t>Arbitrage : privilégier la robustesse du moteur d’import plutôt que le calendrier initial.</a:t>
             </a:r>
-            <a:endParaRPr lang="en-US" sz="1400" dirty="0"/>
+            <a:endParaRPr lang="en-US" sz="2000" dirty="0"/>
           </a:p>
         </p:txBody>
       </p:sp>
@@ -15691,7 +15724,7 @@
           <p:nvPr/>
         </p:nvSpPr>
         <p:spPr>
-          <a:xfrm rot="900000">
+          <a:xfrm>
             <a:off x="10922000" y="254000"/>
             <a:ext cx="457200" cy="457200"/>
           </a:xfrm>
@@ -15755,7 +15788,7 @@
                 <a:ea typeface="JetBrains Mono" pitchFamily="34" charset="-122"/>
                 <a:cs typeface="JetBrains Mono" pitchFamily="34" charset="-120"/>
               </a:rPr>
-              <a:t>09 / 15 — DÉMARCHE</a:t>
+              <a:t>09 / 15 — RÉSULTATS</a:t>
             </a:r>
             <a:endParaRPr lang="en-US" sz="1200" dirty="0"/>
           </a:p>
@@ -15877,7 +15910,7 @@
                 <a:ea typeface="Space Grotesk" pitchFamily="34" charset="-122"/>
                 <a:cs typeface="Space Grotesk" pitchFamily="34" charset="-120"/>
               </a:rPr>
-              <a:t>Un mois de décalage en fin de projet</a:t>
+              <a:t>RIPTIS en production le 20 août 2026</a:t>
             </a:r>
             <a:endParaRPr lang="en-US" sz="3600" dirty="0"/>
           </a:p>
@@ -15892,7 +15925,7 @@
         <p:spPr>
           <a:xfrm>
             <a:off x="812800" y="1587500"/>
-            <a:ext cx="6985000" cy="3625850"/>
+            <a:ext cx="6096000" cy="4044950"/>
           </a:xfrm>
           <a:prstGeom prst="rect">
             <a:avLst/>
@@ -15917,7 +15950,7 @@
       </p:sp>
       <p:pic>
         <p:nvPicPr>
-          <p:cNvPr id="12" name="Image 2" descr="Planning prévisionnel et réalisé sur la même échelle de temps">    </p:cNvPr>
+          <p:cNvPr id="12" name="Image 2" descr="Tableau de bord d’accueil de RIPTIS : 2 432 matrices centralisées">    </p:cNvPr>
           <p:cNvPicPr>
             <a:picLocks noChangeAspect="1"/>
           </p:cNvPicPr>
@@ -15932,7 +15965,7 @@
         <p:spPr>
           <a:xfrm>
             <a:off x="838200" y="1612900"/>
-            <a:ext cx="6934200" cy="3575050"/>
+            <a:ext cx="6045200" cy="3994150"/>
           </a:xfrm>
           <a:prstGeom prst="rect">
             <a:avLst/>
@@ -15941,85 +15974,14 @@
       </p:pic>
       <p:sp>
         <p:nvSpPr>
-          <p:cNvPr id="13" name="Shape 7"/>
-          <p:cNvSpPr/>
-          <p:nvPr/>
-        </p:nvSpPr>
-        <p:spPr>
-          <a:xfrm>
-            <a:off x="8102600" y="1587500"/>
-            <a:ext cx="3276600" cy="1397000"/>
-          </a:xfrm>
-          <a:prstGeom prst="rect">
-            <a:avLst/>
-          </a:prstGeom>
-          <a:solidFill>
-            <a:srgbClr val="FBF9F3"/>
-          </a:solidFill>
-          <a:ln w="25400">
-            <a:solidFill>
-              <a:srgbClr val="16181D"/>
-            </a:solidFill>
-            <a:prstDash val="solid"/>
-          </a:ln>
-          <a:effectLst>
-            <a:outerShdw sx="100000" sy="100000" kx="0" ky="0" algn="bl" rotWithShape="0" blurRad="101600" dist="63500" dir="2700000">
-              <a:srgbClr val="16181D">
-                <a:alpha val="100000"/>
-              </a:srgbClr>
-            </a:outerShdw>
-          </a:effectLst>
-        </p:spPr>
-      </p:sp>
-      <p:sp>
-        <p:nvSpPr>
-          <p:cNvPr id="14" name="Text 8"/>
+          <p:cNvPr id="13" name="Text 7"/>
           <p:cNvSpPr txBox="1"/>
           <p:nvPr/>
         </p:nvSpPr>
         <p:spPr>
           <a:xfrm>
-            <a:off x="8331200" y="1841500"/>
-            <a:ext cx="2794000" cy="215900"/>
-          </a:xfrm>
-          <a:prstGeom prst="rect">
-            <a:avLst/>
-          </a:prstGeom>
-          <a:noFill/>
-          <a:ln/>
-        </p:spPr>
-        <p:txBody>
-          <a:bodyPr wrap="square" lIns="0" tIns="0" rIns="0" bIns="0" rtlCol="0" anchor="t"/>
-          <a:lstStyle/>
-          <a:p>
-            <a:pPr indent="0" marL="0">
-              <a:buNone/>
-            </a:pPr>
-            <a:r>
-              <a:rPr lang="en-US" sz="1200" b="1" spc="200" kern="0" dirty="0">
-                <a:solidFill>
-                  <a:srgbClr val="0B4F7A"/>
-                </a:solidFill>
-                <a:latin typeface="JetBrains Mono" pitchFamily="34" charset="0"/>
-                <a:ea typeface="JetBrains Mono" pitchFamily="34" charset="-122"/>
-                <a:cs typeface="JetBrains Mono" pitchFamily="34" charset="-120"/>
-              </a:rPr>
-              <a:t>PRÉVU</a:t>
-            </a:r>
-            <a:endParaRPr lang="en-US" sz="1200" dirty="0"/>
-          </a:p>
-        </p:txBody>
-      </p:sp>
-      <p:sp>
-        <p:nvSpPr>
-          <p:cNvPr id="15" name="Text 9"/>
-          <p:cNvSpPr txBox="1"/>
-          <p:nvPr/>
-        </p:nvSpPr>
-        <p:spPr>
-          <a:xfrm>
-            <a:off x="8331200" y="2222500"/>
-            <a:ext cx="2794000" cy="406400"/>
+            <a:off x="7213600" y="1587500"/>
+            <a:ext cx="4165600" cy="355600"/>
           </a:xfrm>
           <a:prstGeom prst="rect">
             <a:avLst/>
@@ -16037,13 +15999,13 @@
             <a:r>
               <a:rPr lang="en-US" sz="2000" b="1" dirty="0">
                 <a:solidFill>
-                  <a:srgbClr val="16181D"/>
+                  <a:srgbClr val="0B4F7A"/>
                 </a:solidFill>
                 <a:latin typeface="Space Grotesk" pitchFamily="34" charset="0"/>
                 <a:ea typeface="Space Grotesk" pitchFamily="34" charset="-122"/>
                 <a:cs typeface="Space Grotesk" pitchFamily="34" charset="-120"/>
               </a:rPr>
-              <a:t>Juillet 2026</a:t>
+              <a:t>2 432 matrices</a:t>
             </a:r>
             <a:endParaRPr lang="en-US" sz="2000" dirty="0"/>
           </a:p>
@@ -16051,46 +16013,14 @@
       </p:sp>
       <p:sp>
         <p:nvSpPr>
-          <p:cNvPr id="16" name="Shape 10"/>
-          <p:cNvSpPr/>
-          <p:nvPr/>
-        </p:nvSpPr>
-        <p:spPr>
-          <a:xfrm>
-            <a:off x="8102600" y="3136900"/>
-            <a:ext cx="3276600" cy="1397000"/>
-          </a:xfrm>
-          <a:prstGeom prst="rect">
-            <a:avLst/>
-          </a:prstGeom>
-          <a:solidFill>
-            <a:srgbClr val="FBF9F3"/>
-          </a:solidFill>
-          <a:ln w="25400">
-            <a:solidFill>
-              <a:srgbClr val="16181D"/>
-            </a:solidFill>
-            <a:prstDash val="solid"/>
-          </a:ln>
-          <a:effectLst>
-            <a:outerShdw sx="100000" sy="100000" kx="0" ky="0" algn="bl" rotWithShape="0" blurRad="101600" dist="63500" dir="2700000">
-              <a:srgbClr val="16181D">
-                <a:alpha val="100000"/>
-              </a:srgbClr>
-            </a:outerShdw>
-          </a:effectLst>
-        </p:spPr>
-      </p:sp>
-      <p:sp>
-        <p:nvSpPr>
-          <p:cNvPr id="17" name="Text 11"/>
+          <p:cNvPr id="14" name="Text 8"/>
           <p:cNvSpPr txBox="1"/>
           <p:nvPr/>
         </p:nvSpPr>
         <p:spPr>
           <a:xfrm>
-            <a:off x="8331200" y="3390900"/>
-            <a:ext cx="2794000" cy="215900"/>
+            <a:off x="7213600" y="2159000"/>
+            <a:ext cx="4165600" cy="2667000"/>
           </a:xfrm>
           <a:prstGeom prst="rect">
             <a:avLst/>
@@ -16102,60 +16032,130 @@
           <a:bodyPr wrap="square" lIns="0" tIns="0" rIns="0" bIns="0" rtlCol="0" anchor="t"/>
           <a:lstStyle/>
           <a:p>
-            <a:pPr indent="0" marL="0">
-              <a:buNone/>
+            <a:pPr marL="279400" indent="-279400">
+              <a:spcAft>
+                <a:spcPts val="800"/>
+              </a:spcAft>
+              <a:buSzPct val="100000"/>
+              <a:buChar char="•"/>
             </a:pPr>
             <a:r>
-              <a:rPr lang="en-US" sz="1200" b="1" spc="200" kern="0" dirty="0">
-                <a:solidFill>
-                  <a:srgbClr val="0B4F7A"/>
-                </a:solidFill>
-                <a:latin typeface="JetBrains Mono" pitchFamily="34" charset="0"/>
-                <a:ea typeface="JetBrains Mono" pitchFamily="34" charset="-122"/>
-                <a:cs typeface="JetBrains Mono" pitchFamily="34" charset="-120"/>
-              </a:rPr>
-              <a:t>RÉALISÉ</a:t>
-            </a:r>
-            <a:endParaRPr lang="en-US" sz="1200" dirty="0"/>
-          </a:p>
-        </p:txBody>
-      </p:sp>
-      <p:sp>
-        <p:nvSpPr>
-          <p:cNvPr id="18" name="Text 12"/>
-          <p:cNvSpPr txBox="1"/>
-          <p:nvPr/>
-        </p:nvSpPr>
-        <p:spPr>
-          <a:xfrm>
-            <a:off x="8331200" y="3771900"/>
-            <a:ext cx="2794000" cy="406400"/>
-          </a:xfrm>
-          <a:prstGeom prst="rect">
-            <a:avLst/>
-          </a:prstGeom>
-          <a:noFill/>
-          <a:ln/>
-        </p:spPr>
-        <p:txBody>
-          <a:bodyPr wrap="square" lIns="0" tIns="0" rIns="0" bIns="0" rtlCol="0" anchor="t"/>
-          <a:lstStyle/>
-          <a:p>
-            <a:pPr indent="0" marL="0">
-              <a:buNone/>
-            </a:pPr>
-            <a:r>
-              <a:rPr lang="en-US" sz="2000" b="1" dirty="0">
+              <a:rPr lang="en-US" sz="1600" dirty="0">
                 <a:solidFill>
                   <a:srgbClr val="16181D"/>
                 </a:solidFill>
-                <a:latin typeface="Space Grotesk" pitchFamily="34" charset="0"/>
-                <a:ea typeface="Space Grotesk" pitchFamily="34" charset="-122"/>
-                <a:cs typeface="Space Grotesk" pitchFamily="34" charset="-120"/>
+                <a:latin typeface="IBM Plex Sans" pitchFamily="34" charset="0"/>
+                <a:ea typeface="IBM Plex Sans" pitchFamily="34" charset="-122"/>
+                <a:cs typeface="IBM Plex Sans" pitchFamily="34" charset="-120"/>
               </a:rPr>
-              <a:t>20 août 2026</a:t>
+              <a:t>Import Excel multi-formats</a:t>
             </a:r>
-            <a:endParaRPr lang="en-US" sz="2000" dirty="0"/>
+            <a:endParaRPr lang="en-US" sz="1600" dirty="0"/>
+          </a:p>
+          <a:p>
+            <a:pPr marL="279400" indent="-279400">
+              <a:spcAft>
+                <a:spcPts val="800"/>
+              </a:spcAft>
+              <a:buSzPct val="100000"/>
+              <a:buChar char="•"/>
+            </a:pPr>
+            <a:r>
+              <a:rPr lang="en-US" sz="1600" dirty="0">
+                <a:solidFill>
+                  <a:srgbClr val="16181D"/>
+                </a:solidFill>
+                <a:latin typeface="IBM Plex Sans" pitchFamily="34" charset="0"/>
+                <a:ea typeface="IBM Plex Sans" pitchFamily="34" charset="-122"/>
+                <a:cs typeface="IBM Plex Sans" pitchFamily="34" charset="-120"/>
+              </a:rPr>
+              <a:t>Recherche multicritère</a:t>
+            </a:r>
+            <a:endParaRPr lang="en-US" sz="1600" dirty="0"/>
+          </a:p>
+          <a:p>
+            <a:pPr marL="279400" indent="-279400">
+              <a:spcAft>
+                <a:spcPts val="800"/>
+              </a:spcAft>
+              <a:buSzPct val="100000"/>
+              <a:buChar char="•"/>
+            </a:pPr>
+            <a:r>
+              <a:rPr lang="en-US" sz="1600" dirty="0">
+                <a:solidFill>
+                  <a:srgbClr val="16181D"/>
+                </a:solidFill>
+                <a:latin typeface="IBM Plex Sans" pitchFamily="34" charset="0"/>
+                <a:ea typeface="IBM Plex Sans" pitchFamily="34" charset="-122"/>
+                <a:cs typeface="IBM Plex Sans" pitchFamily="34" charset="-120"/>
+              </a:rPr>
+              <a:t>Recherche DNS</a:t>
+            </a:r>
+            <a:endParaRPr lang="en-US" sz="1600" dirty="0"/>
+          </a:p>
+          <a:p>
+            <a:pPr marL="279400" indent="-279400">
+              <a:spcAft>
+                <a:spcPts val="800"/>
+              </a:spcAft>
+              <a:buSzPct val="100000"/>
+              <a:buChar char="•"/>
+            </a:pPr>
+            <a:r>
+              <a:rPr lang="en-US" sz="1600" dirty="0">
+                <a:solidFill>
+                  <a:srgbClr val="16181D"/>
+                </a:solidFill>
+                <a:latin typeface="IBM Plex Sans" pitchFamily="34" charset="0"/>
+                <a:ea typeface="IBM Plex Sans" pitchFamily="34" charset="-122"/>
+                <a:cs typeface="IBM Plex Sans" pitchFamily="34" charset="-120"/>
+              </a:rPr>
+              <a:t>Droits par OIDC</a:t>
+            </a:r>
+            <a:endParaRPr lang="en-US" sz="1600" dirty="0"/>
+          </a:p>
+          <a:p>
+            <a:pPr marL="279400" indent="-279400">
+              <a:spcAft>
+                <a:spcPts val="800"/>
+              </a:spcAft>
+              <a:buSzPct val="100000"/>
+              <a:buChar char="•"/>
+            </a:pPr>
+            <a:r>
+              <a:rPr lang="en-US" sz="1600" dirty="0">
+                <a:solidFill>
+                  <a:srgbClr val="16181D"/>
+                </a:solidFill>
+                <a:latin typeface="IBM Plex Sans" pitchFamily="34" charset="0"/>
+                <a:ea typeface="IBM Plex Sans" pitchFamily="34" charset="-122"/>
+                <a:cs typeface="IBM Plex Sans" pitchFamily="34" charset="-120"/>
+              </a:rPr>
+              <a:t>Export Excel</a:t>
+            </a:r>
+            <a:endParaRPr lang="en-US" sz="1600" dirty="0"/>
+          </a:p>
+          <a:p>
+            <a:pPr marL="279400" indent="-279400">
+              <a:spcAft>
+                <a:spcPts val="800"/>
+              </a:spcAft>
+              <a:buSzPct val="100000"/>
+              <a:buChar char="•"/>
+            </a:pPr>
+            <a:r>
+              <a:rPr lang="en-US" sz="1600" dirty="0">
+                <a:solidFill>
+                  <a:srgbClr val="16181D"/>
+                </a:solidFill>
+                <a:latin typeface="IBM Plex Sans" pitchFamily="34" charset="0"/>
+                <a:ea typeface="IBM Plex Sans" pitchFamily="34" charset="-122"/>
+                <a:cs typeface="IBM Plex Sans" pitchFamily="34" charset="-120"/>
+              </a:rPr>
+              <a:t>Sauvegarde PostgreSQL</a:t>
+            </a:r>
+            <a:endParaRPr lang="en-US" sz="1600" dirty="0"/>
           </a:p>
         </p:txBody>
       </p:sp>

</xml_diff>

<commit_message>
Conclusion: replace recommendations with key takeaways
Co-Authored-By: Claude Sonnet 5.5 <noreply@anthropic.com>
Claude-Session: https://claude.ai/code/session_01XNTjksxVUQQ2s2meKajJig
</commit_message>
<xml_diff>
--- a/Presentation_RIPTIS.pptx
+++ b/Presentation_RIPTIS.pptx
@@ -7845,7 +7845,7 @@
                 <a:ea typeface="JetBrains Mono" pitchFamily="34" charset="-122"/>
                 <a:cs typeface="JetBrains Mono" pitchFamily="34" charset="-120"/>
               </a:rPr>
-              <a:t>TROIS PRÉCONISATIONS</a:t>
+              <a:t>À RETENIR</a:t>
             </a:r>
             <a:endParaRPr lang="en-US" sz="1200" dirty="0"/>
           </a:p>
@@ -7923,7 +7923,7 @@
                 <a:ea typeface="IBM Plex Sans" pitchFamily="34" charset="-122"/>
                 <a:cs typeface="IBM Plex Sans" pitchFamily="34" charset="-120"/>
               </a:rPr>
-              <a:t>Instrumenter la mesure d’impact dès le lancement du projet</a:t>
+              <a:t>Un besoin réel comblé : 2 432 matrices centralisées et consultables en quelques secondes</a:t>
             </a:r>
             <a:endParaRPr lang="en-US" sz="1600" dirty="0"/>
           </a:p>
@@ -8001,7 +8001,7 @@
                 <a:ea typeface="IBM Plex Sans" pitchFamily="34" charset="-122"/>
                 <a:cs typeface="IBM Plex Sans" pitchFamily="34" charset="-120"/>
               </a:rPr>
-              <a:t>Prévoir une marge pour l’hétérogénéité des données historiques</a:t>
+              <a:t>Mise en production le 20 août 2026, avec un mois de décalage assumé pour la robustesse de l’import</a:t>
             </a:r>
             <a:endParaRPr lang="en-US" sz="1600" dirty="0"/>
           </a:p>
@@ -8079,7 +8079,7 @@
                 <a:ea typeface="IBM Plex Sans" pitchFamily="34" charset="-122"/>
                 <a:cs typeface="IBM Plex Sans" pitchFamily="34" charset="-120"/>
               </a:rPr>
-              <a:t>Ouvrir RIPTIS à d’autres outils réseau</a:t>
+              <a:t>Une expérience de co-pilotage technique en autonomie, transférable au métier d’ingénieur</a:t>
             </a:r>
             <a:endParaRPr lang="en-US" sz="1600" dirty="0"/>
           </a:p>

</xml_diff>

<commit_message>
Skills slide: add teamwork competence
Co-Authored-By: Claude Sonnet 5.5 <noreply@anthropic.com>
Claude-Session: https://claude.ai/code/session_01XNTjksxVUQQ2s2meKajJig
</commit_message>
<xml_diff>
--- a/Presentation_RIPTIS.pptx
+++ b/Presentation_RIPTIS.pptx
@@ -6133,7 +6133,7 @@
         <p:spPr>
           <a:xfrm>
             <a:off x="812800" y="1587500"/>
-            <a:ext cx="5156200" cy="3302000"/>
+            <a:ext cx="5156200" cy="3683000"/>
           </a:xfrm>
           <a:prstGeom prst="rect">
             <a:avLst/>
@@ -6311,6 +6311,30 @@
             </a:r>
             <a:endParaRPr lang="en-US" sz="1600" dirty="0"/>
           </a:p>
+          <a:p>
+            <a:pPr marL="279400" indent="-279400">
+              <a:lnSpc>
+                <a:spcPct val="105000"/>
+              </a:lnSpc>
+              <a:spcAft>
+                <a:spcPts val="800"/>
+              </a:spcAft>
+              <a:buSzPct val="100000"/>
+              <a:buChar char="•"/>
+            </a:pPr>
+            <a:r>
+              <a:rPr lang="en-US" sz="1600" dirty="0">
+                <a:solidFill>
+                  <a:srgbClr val="16181D"/>
+                </a:solidFill>
+                <a:latin typeface="IBM Plex Sans" pitchFamily="34" charset="0"/>
+                <a:ea typeface="IBM Plex Sans" pitchFamily="34" charset="-122"/>
+                <a:cs typeface="IBM Plex Sans" pitchFamily="34" charset="-120"/>
+              </a:rPr>
+              <a:t>Travail en équipe : réseau, IT/Infra, maître d’apprentissage</a:t>
+            </a:r>
+            <a:endParaRPr lang="en-US" sz="1600" dirty="0"/>
+          </a:p>
         </p:txBody>
       </p:sp>
       <p:sp>
@@ -6322,7 +6346,7 @@
         <p:spPr>
           <a:xfrm>
             <a:off x="6223000" y="1587500"/>
-            <a:ext cx="5156200" cy="3302000"/>
+            <a:ext cx="5156200" cy="3683000"/>
           </a:xfrm>
           <a:prstGeom prst="rect">
             <a:avLst/>

</xml_diff>

<commit_message>
Imprévus: Logtis P1 project; critical feedback: plan for contingencies
Co-Authored-By: Claude Sonnet 5.5 <noreply@anthropic.com>
Claude-Session: https://claude.ai/code/session_01XNTjksxVUQQ2s2meKajJig
</commit_message>
<xml_diff>
--- a/Presentation_RIPTIS.pptx
+++ b/Presentation_RIPTIS.pptx
@@ -868,7 +868,7 @@
           <a:p>
             <a:r>
               <a:rPr lang="en-US" dirty="0"/>
-              <a:t>Techniquement, la conception du moteur d’import a été la difficulté la plus formatrice. Côté gestion de projet, ma principale limite est de ne pas avoir instrumenté la mesure d’impact dès le début.</a:t>
+              <a:t>Techniquement, la conception du moteur d’import a été la difficulté la plus formatrice. Côté gestion de projet, mon principal retour critique : mon planning ne prévoyait pas de marge pour les imprévus. Je prévoirai cette marge dès la construction du planning.</a:t>
             </a:r>
             <a:endParaRPr lang="en-US" dirty="0"/>
           </a:p>
@@ -1572,7 +1572,7 @@
           <a:p>
             <a:r>
               <a:rPr lang="en-US" dirty="0"/>
-              <a:t>Cadrage, développement et tests sont conformes au prévisionnel. L’écart d’environ un mois vient d’une seule cause : le volume de cas particuliers découverts pendant les tests, qui a ajouté une étape de traitement et décalé la stabilisation.</a:t>
+              <a:t>Cadrage, développement et tests sont conformes au prévisionnel. L’écart d’environ un mois a deux origines : le projet Logtis, passé en P1 devant RIPTIS, et le volume de cas particuliers découverts pendant les tests, qui a ajouté une étape de traitement et décalé la stabilisation.</a:t>
             </a:r>
             <a:endParaRPr lang="en-US" dirty="0"/>
           </a:p>
@@ -1660,7 +1660,7 @@
           <a:p>
             <a:r>
               <a:rPr lang="en-US" dirty="0"/>
-              <a:t>Le premier imprévu a été limité par une demande d’accès anticipée. Le second m’a conduit à généraliser le moteur d’import plutôt que traiter les fichiers un par un : c’est ce choix qui explique le mois de retard, validé avec mon maître d’apprentissage.</a:t>
+              <a:t>Premier imprévu : un projet Logtis est passé en priorité P1 devant RIPTIS, ce qui a décalé les tâches de RIPTIS. Second imprévu : l’hétérogénéité des fichiers Excel. Une vingtaine de fichiers particuliers m’ont conduit à généraliser le moteur d’import plutôt que de les traiter un par un : j’ai privilégié la robustesse, avec l’accord de mon maître d’apprentissage.</a:t>
             </a:r>
             <a:endParaRPr lang="en-US" dirty="0"/>
           </a:p>
@@ -6444,7 +6444,7 @@
                 <a:ea typeface="IBM Plex Sans" pitchFamily="34" charset="-122"/>
                 <a:cs typeface="IBM Plex Sans" pitchFamily="34" charset="-120"/>
               </a:rPr>
-              <a:t>Pas de chronométrage avant/après dès le cadrage : les gains reposent sur une estimation.</a:t>
+              <a:t>Le planning initial ne prévoyait pas de marge pour les imprévus : le projet Logtis passé en P1 et les fichiers hétérogènes ont décalé la mise en production.</a:t>
             </a:r>
             <a:endParaRPr lang="en-US" sz="1600" dirty="0"/>
           </a:p>
@@ -6486,7 +6486,7 @@
                 <a:ea typeface="IBM Plex Sans" pitchFamily="34" charset="-122"/>
                 <a:cs typeface="IBM Plex Sans" pitchFamily="34" charset="-120"/>
               </a:rPr>
-              <a:t>La mesure d’impact aurait dû être instrumentée dès la note de cadrage.</a:t>
+              <a:t>Prévoir une marge pour les imprévus dès la construction du planning.</a:t>
             </a:r>
             <a:endParaRPr lang="en-US" sz="1600" dirty="0"/>
           </a:p>
@@ -15388,7 +15388,7 @@
                 <a:ea typeface="Space Grotesk" pitchFamily="34" charset="-122"/>
                 <a:cs typeface="Space Grotesk" pitchFamily="34" charset="-120"/>
               </a:rPr>
-              <a:t>Accès et droits</a:t>
+              <a:t>Projet Logtis prioritaire</a:t>
             </a:r>
             <a:endParaRPr lang="en-US" sz="2000" dirty="0"/>
           </a:p>
@@ -15430,7 +15430,7 @@
                 <a:ea typeface="IBM Plex Sans" pitchFamily="34" charset="-122"/>
                 <a:cs typeface="IBM Plex Sans" pitchFamily="34" charset="-120"/>
               </a:rPr>
-              <a:t>Autorisations nécessaires avant de pouvoir développer et tester. Demande anticipée dès mars 2026.</a:t>
+              <a:t>Un projet Logtis, passé en P1 devant RIPTIS, a décalé les tâches de RIPTIS.</a:t>
             </a:r>
             <a:endParaRPr lang="en-US" sz="1600" dirty="0"/>
           </a:p>

</xml_diff>

<commit_message>
Feedback round: referential title, app modules split, 3rd imprévu (Nexus), bilan statuses, positive adaptability, closing question
Co-Authored-By: Claude Sonnet 5.5 <noreply@anthropic.com>
Claude-Session: https://claude.ai/code/session_01XNTjksxVUQQ2s2meKajJig
</commit_message>
<xml_diff>
--- a/Presentation_RIPTIS.pptx
+++ b/Presentation_RIPTIS.pptx
@@ -516,7 +516,7 @@
           <a:p>
             <a:r>
               <a:rPr lang="en-US" dirty="0"/>
-              <a:t>Bonjour. Je présente RIPTIS, l’application web que j’ai conçue, développée et mise en production chez Transactis entre mars et août 2026, en alternance.</a:t>
+              <a:t>Bonjour. Je présente RIPTIS, un référentiel de flux réseau sous forme d’application web, que j’ai conçu, développé et mis en production chez Transactis entre mars et août 2026, en alternance.</a:t>
             </a:r>
             <a:endParaRPr lang="en-US" dirty="0"/>
           </a:p>
@@ -780,7 +780,7 @@
           <a:p>
             <a:r>
               <a:rPr lang="en-US" dirty="0"/>
-              <a:t>Les objectifs de sécurité et de centralisation sont atteints. Les objectifs quantitatifs reposent encore sur des estimations : la clôture du projet doit produire les mesures définitives.</a:t>
+              <a:t>Les objectifs de sécurité, de centralisation, de formats historiques, de sauvegarde et de temps de réponse des requêtes sont atteints. Côté satisfaction, mes collaborateurs trouvent l’outil génial ; un formulaire de satisfaction va permettre de le mesurer. Le gain de 70 % sur la recherche reste à chronométrer.</a:t>
             </a:r>
             <a:endParaRPr lang="en-US" dirty="0"/>
           </a:p>
@@ -868,7 +868,7 @@
           <a:p>
             <a:r>
               <a:rPr lang="en-US" dirty="0"/>
-              <a:t>Techniquement, la conception du moteur d’import a été la difficulté la plus formatrice. Côté gestion de projet, mon principal retour critique : mon planning ne prévoyait pas de marge pour les imprévus. Je prévoirai cette marge dès la construction du planning.</a:t>
+              <a:t>Techniquement, la conception du moteur d’import a été la difficulté la plus formatrice. Côté gestion de projet, j’ai appris à m’adapter : face à trois imprévus, j’ai priorisé et arbitré sans renoncer à la mise en production. J’en retiens un réflexe : prévoir une marge pour les imprévus dès la construction du planning.</a:t>
             </a:r>
             <a:endParaRPr lang="en-US" dirty="0"/>
           </a:p>
@@ -1044,7 +1044,7 @@
           <a:p>
             <a:r>
               <a:rPr lang="en-US" dirty="0"/>
-              <a:t>RIPTIS répond au besoin identifié : centraliser des données réseau dispersées, dans le respect des contraintes d’un environnement bancaire. Mise en production le 20 août 2026. Je suis à votre disposition pour vos questions.</a:t>
+              <a:t>RIPTIS répond au besoin identifié : centraliser des données réseau dispersées, dans le respect des contraintes d’un environnement bancaire. Mise en production le 20 août 2026. Je termine par une question : et si retrouver un flux réseau prenait 30 secondes ? [pause] Merci de votre attention, je suis à votre disposition pour vos questions.</a:t>
             </a:r>
             <a:endParaRPr lang="en-US" dirty="0"/>
           </a:p>
@@ -1572,7 +1572,7 @@
           <a:p>
             <a:r>
               <a:rPr lang="en-US" dirty="0"/>
-              <a:t>Cadrage, développement et tests sont conformes au prévisionnel. L’écart d’environ un mois a deux origines : le projet Logtis, passé en P1 devant RIPTIS, et le volume de cas particuliers découverts pendant les tests, qui a ajouté une étape de traitement et décalé la stabilisation.</a:t>
+              <a:t>Cadrage, développement et tests sont conformes au prévisionnel. La mise en production est décalée d’environ un mois ; les causes sont détaillées à la diapo suivante.</a:t>
             </a:r>
             <a:endParaRPr lang="en-US" dirty="0"/>
           </a:p>
@@ -1660,7 +1660,7 @@
           <a:p>
             <a:r>
               <a:rPr lang="en-US" dirty="0"/>
-              <a:t>Premier imprévu : un projet Logtis est passé en priorité P1 devant RIPTIS, ce qui a décalé les tâches de RIPTIS. Second imprévu : l’hétérogénéité des fichiers Excel. Une vingtaine de fichiers particuliers m’ont conduit à généraliser le moteur d’import plutôt que de les traiter un par un : j’ai privilégié la robustesse, avec l’accord de mon maître d’apprentissage.</a:t>
+              <a:t>Premier imprévu : un projet Logtis est passé en priorité P1 devant RIPTIS, ce qui a décalé les tâches de RIPTIS. Deuxième imprévu : l’hétérogénéité des fichiers Excel ; une vingtaine de fichiers particuliers m’ont conduit à généraliser le moteur d’import plutôt que de les traiter un par un. Troisième imprévu : une instance externe a alerté Transactis sur de potentielles vulnérabilités liées à Nexus, l’outil de gestion des librairies. Il fallait cesser de l’utiliser et trouver une alternative pour installer les packages. À chaque fois, j’ai priorisé et privilégié la robustesse.</a:t>
             </a:r>
             <a:endParaRPr lang="en-US" dirty="0"/>
           </a:p>
@@ -1748,7 +1748,7 @@
           <a:p>
             <a:r>
               <a:rPr lang="en-US" dirty="0"/>
-              <a:t>Sept livrables : application web, import Excel, recherche multicritère, recherche DNS, gestion des utilisateurs, export et sauvegarde. Mise en production le 20 août 2026 sur Docker, Jenkins et Kubernetes.</a:t>
+              <a:t>Le socle initial : import Excel multi-formats, recherche multicritère, export, droits par OIDC et sauvegarde. En cours de projet, des modules sont venus s’ajouter : recherche DNS, VPN, RSSI et REF IP. Mise en production le 20 août 2026 sur Docker, Jenkins et Kubernetes.</a:t>
             </a:r>
             <a:endParaRPr lang="en-US" dirty="0"/>
           </a:p>
@@ -2442,7 +2442,7 @@
                 <a:ea typeface="IBM Plex Sans" pitchFamily="34" charset="-122"/>
                 <a:cs typeface="IBM Plex Sans" pitchFamily="34" charset="-120"/>
               </a:rPr>
-              <a:t>Application web de centralisation des flux réseau</a:t>
+              <a:t>Application web : référentiel de flux réseau</a:t>
             </a:r>
             <a:endParaRPr lang="en-US" sz="2400" dirty="0"/>
           </a:p>
@@ -5089,7 +5089,7 @@
                           <a:ea typeface="IBM Plex Sans" pitchFamily="34" charset="-122"/>
                           <a:cs typeface="IBM Plex Sans" pitchFamily="34" charset="-120"/>
                         </a:rPr>
-                        <a:t>Sauvegarde en place, procédure à écrire</a:t>
+                        <a:t>Sauvegarde mise en place</a:t>
                       </a:r>
                       <a:endParaRPr lang="en-US" sz="1500" dirty="0">
                         <a:latin typeface="IBM Plex Sans" charset="0"/>
@@ -5157,7 +5157,213 @@
                           <a:ea typeface="IBM Plex Sans" pitchFamily="34" charset="-122"/>
                           <a:cs typeface="IBM Plex Sans" pitchFamily="34" charset="-120"/>
                         </a:rPr>
-                        <a:t>Partiel</a:t>
+                        <a:t>Atteint</a:t>
+                      </a:r>
+                      <a:endParaRPr lang="en-US" sz="1500" dirty="0">
+                        <a:latin typeface="IBM Plex Sans" charset="0"/>
+                        <a:ea typeface="IBM Plex Sans" charset="0"/>
+                        <a:cs typeface="IBM Plex Sans" charset="0"/>
+                      </a:endParaRPr>
+                    </a:p>
+                  </a:txBody>
+                  <a:tcPr marL="91440" marR="91440" marT="45720" marB="45720" anchor="ctr">
+                    <a:lnL w="19050" cap="flat" cmpd="sng" algn="ctr">
+                      <a:solidFill>
+                        <a:srgbClr val="16181D"/>
+                      </a:solidFill>
+                      <a:prstDash val="solid"/>
+                      <a:round/>
+                      <a:headEnd type="none" w="med" len="med"/>
+                      <a:tailEnd type="none" w="med" len="med"/>
+                    </a:lnL>
+                    <a:lnR w="19050" cap="flat" cmpd="sng" algn="ctr">
+                      <a:solidFill>
+                        <a:srgbClr val="16181D"/>
+                      </a:solidFill>
+                      <a:prstDash val="solid"/>
+                      <a:round/>
+                      <a:headEnd type="none" w="med" len="med"/>
+                      <a:tailEnd type="none" w="med" len="med"/>
+                    </a:lnR>
+                    <a:lnT w="19050" cap="flat" cmpd="sng" algn="ctr">
+                      <a:solidFill>
+                        <a:srgbClr val="16181D"/>
+                      </a:solidFill>
+                      <a:prstDash val="solid"/>
+                      <a:round/>
+                      <a:headEnd type="none" w="med" len="med"/>
+                      <a:tailEnd type="none" w="med" len="med"/>
+                    </a:lnT>
+                    <a:lnB w="19050" cap="flat" cmpd="sng" algn="ctr">
+                      <a:solidFill>
+                        <a:srgbClr val="16181D"/>
+                      </a:solidFill>
+                      <a:prstDash val="solid"/>
+                      <a:round/>
+                      <a:headEnd type="none" w="med" len="med"/>
+                      <a:tailEnd type="none" w="med" len="med"/>
+                    </a:lnB>
+                    <a:solidFill>
+                      <a:srgbClr val="FBF9F3"/>
+                    </a:solidFill>
+                  </a:tcPr>
+                </a:tc>
+              </a:tr>
+              <a:tr h="431800">
+                <a:tc>
+                  <a:txBody>
+                    <a:bodyPr/>
+                    <a:lstStyle/>
+                    <a:p>
+                      <a:pPr indent="0" marL="0">
+                        <a:buNone/>
+                      </a:pPr>
+                      <a:r>
+                        <a:rPr lang="en-US" sz="1500" dirty="0">
+                          <a:solidFill>
+                            <a:srgbClr val="16181D"/>
+                          </a:solidFill>
+                          <a:latin typeface="IBM Plex Sans" pitchFamily="34" charset="0"/>
+                          <a:ea typeface="IBM Plex Sans" pitchFamily="34" charset="-122"/>
+                          <a:cs typeface="IBM Plex Sans" pitchFamily="34" charset="-120"/>
+                        </a:rPr>
+                        <a:t>Réponse &lt; 2 secondes</a:t>
+                      </a:r>
+                      <a:endParaRPr lang="en-US" sz="1500" dirty="0">
+                        <a:latin typeface="IBM Plex Sans" charset="0"/>
+                        <a:ea typeface="IBM Plex Sans" charset="0"/>
+                        <a:cs typeface="IBM Plex Sans" charset="0"/>
+                      </a:endParaRPr>
+                    </a:p>
+                  </a:txBody>
+                  <a:tcPr marL="91440" marR="91440" marT="45720" marB="45720" anchor="ctr">
+                    <a:lnL w="19050" cap="flat" cmpd="sng" algn="ctr">
+                      <a:solidFill>
+                        <a:srgbClr val="16181D"/>
+                      </a:solidFill>
+                      <a:prstDash val="solid"/>
+                      <a:round/>
+                      <a:headEnd type="none" w="med" len="med"/>
+                      <a:tailEnd type="none" w="med" len="med"/>
+                    </a:lnL>
+                    <a:lnR w="19050" cap="flat" cmpd="sng" algn="ctr">
+                      <a:solidFill>
+                        <a:srgbClr val="16181D"/>
+                      </a:solidFill>
+                      <a:prstDash val="solid"/>
+                      <a:round/>
+                      <a:headEnd type="none" w="med" len="med"/>
+                      <a:tailEnd type="none" w="med" len="med"/>
+                    </a:lnR>
+                    <a:lnT w="19050" cap="flat" cmpd="sng" algn="ctr">
+                      <a:solidFill>
+                        <a:srgbClr val="16181D"/>
+                      </a:solidFill>
+                      <a:prstDash val="solid"/>
+                      <a:round/>
+                      <a:headEnd type="none" w="med" len="med"/>
+                      <a:tailEnd type="none" w="med" len="med"/>
+                    </a:lnT>
+                    <a:lnB w="19050" cap="flat" cmpd="sng" algn="ctr">
+                      <a:solidFill>
+                        <a:srgbClr val="16181D"/>
+                      </a:solidFill>
+                      <a:prstDash val="solid"/>
+                      <a:round/>
+                      <a:headEnd type="none" w="med" len="med"/>
+                      <a:tailEnd type="none" w="med" len="med"/>
+                    </a:lnB>
+                    <a:solidFill>
+                      <a:srgbClr val="FBF9F3"/>
+                    </a:solidFill>
+                  </a:tcPr>
+                </a:tc>
+                <a:tc>
+                  <a:txBody>
+                    <a:bodyPr/>
+                    <a:lstStyle/>
+                    <a:p>
+                      <a:pPr indent="0" marL="0">
+                        <a:buNone/>
+                      </a:pPr>
+                      <a:r>
+                        <a:rPr lang="en-US" sz="1500" dirty="0">
+                          <a:solidFill>
+                            <a:srgbClr val="16181D"/>
+                          </a:solidFill>
+                          <a:latin typeface="IBM Plex Sans" pitchFamily="34" charset="0"/>
+                          <a:ea typeface="IBM Plex Sans" pitchFamily="34" charset="-122"/>
+                          <a:cs typeface="IBM Plex Sans" pitchFamily="34" charset="-120"/>
+                        </a:rPr>
+                        <a:t>Requêtes base de données rapides</a:t>
+                      </a:r>
+                      <a:endParaRPr lang="en-US" sz="1500" dirty="0">
+                        <a:latin typeface="IBM Plex Sans" charset="0"/>
+                        <a:ea typeface="IBM Plex Sans" charset="0"/>
+                        <a:cs typeface="IBM Plex Sans" charset="0"/>
+                      </a:endParaRPr>
+                    </a:p>
+                  </a:txBody>
+                  <a:tcPr marL="91440" marR="91440" marT="45720" marB="45720" anchor="ctr">
+                    <a:lnL w="19050" cap="flat" cmpd="sng" algn="ctr">
+                      <a:solidFill>
+                        <a:srgbClr val="16181D"/>
+                      </a:solidFill>
+                      <a:prstDash val="solid"/>
+                      <a:round/>
+                      <a:headEnd type="none" w="med" len="med"/>
+                      <a:tailEnd type="none" w="med" len="med"/>
+                    </a:lnL>
+                    <a:lnR w="19050" cap="flat" cmpd="sng" algn="ctr">
+                      <a:solidFill>
+                        <a:srgbClr val="16181D"/>
+                      </a:solidFill>
+                      <a:prstDash val="solid"/>
+                      <a:round/>
+                      <a:headEnd type="none" w="med" len="med"/>
+                      <a:tailEnd type="none" w="med" len="med"/>
+                    </a:lnR>
+                    <a:lnT w="19050" cap="flat" cmpd="sng" algn="ctr">
+                      <a:solidFill>
+                        <a:srgbClr val="16181D"/>
+                      </a:solidFill>
+                      <a:prstDash val="solid"/>
+                      <a:round/>
+                      <a:headEnd type="none" w="med" len="med"/>
+                      <a:tailEnd type="none" w="med" len="med"/>
+                    </a:lnT>
+                    <a:lnB w="19050" cap="flat" cmpd="sng" algn="ctr">
+                      <a:solidFill>
+                        <a:srgbClr val="16181D"/>
+                      </a:solidFill>
+                      <a:prstDash val="solid"/>
+                      <a:round/>
+                      <a:headEnd type="none" w="med" len="med"/>
+                      <a:tailEnd type="none" w="med" len="med"/>
+                    </a:lnB>
+                    <a:solidFill>
+                      <a:srgbClr val="FBF9F3"/>
+                    </a:solidFill>
+                  </a:tcPr>
+                </a:tc>
+                <a:tc>
+                  <a:txBody>
+                    <a:bodyPr/>
+                    <a:lstStyle/>
+                    <a:p>
+                      <a:pPr indent="0" marL="0">
+                        <a:buNone/>
+                      </a:pPr>
+                      <a:r>
+                        <a:rPr lang="en-US" sz="1500" b="1" dirty="0">
+                          <a:solidFill>
+                            <a:srgbClr val="16181D"/>
+                          </a:solidFill>
+                          <a:latin typeface="IBM Plex Sans" pitchFamily="34" charset="0"/>
+                          <a:ea typeface="IBM Plex Sans" pitchFamily="34" charset="-122"/>
+                          <a:cs typeface="IBM Plex Sans" pitchFamily="34" charset="-120"/>
+                        </a:rPr>
+                        <a:t>Atteint</a:t>
                       </a:r>
                       <a:endParaRPr lang="en-US" sz="1500" dirty="0">
                         <a:latin typeface="IBM Plex Sans" charset="0"/>
@@ -5501,7 +5707,7 @@
                           <a:ea typeface="IBM Plex Sans" pitchFamily="34" charset="-122"/>
                           <a:cs typeface="IBM Plex Sans" pitchFamily="34" charset="-120"/>
                         </a:rPr>
-                        <a:t>Retours positifs, sans mesure formelle</a:t>
+                        <a:t>Équipe très satisfaite, formulaire à venir</a:t>
                       </a:r>
                       <a:endParaRPr lang="en-US" sz="1500" dirty="0">
                         <a:latin typeface="IBM Plex Sans" charset="0"/>
@@ -5569,213 +5775,7 @@
                           <a:ea typeface="IBM Plex Sans" pitchFamily="34" charset="-122"/>
                           <a:cs typeface="IBM Plex Sans" pitchFamily="34" charset="-120"/>
                         </a:rPr>
-                        <a:t>À mesurer</a:t>
-                      </a:r>
-                      <a:endParaRPr lang="en-US" sz="1500" dirty="0">
-                        <a:latin typeface="IBM Plex Sans" charset="0"/>
-                        <a:ea typeface="IBM Plex Sans" charset="0"/>
-                        <a:cs typeface="IBM Plex Sans" charset="0"/>
-                      </a:endParaRPr>
-                    </a:p>
-                  </a:txBody>
-                  <a:tcPr marL="91440" marR="91440" marT="45720" marB="45720" anchor="ctr">
-                    <a:lnL w="19050" cap="flat" cmpd="sng" algn="ctr">
-                      <a:solidFill>
-                        <a:srgbClr val="16181D"/>
-                      </a:solidFill>
-                      <a:prstDash val="solid"/>
-                      <a:round/>
-                      <a:headEnd type="none" w="med" len="med"/>
-                      <a:tailEnd type="none" w="med" len="med"/>
-                    </a:lnL>
-                    <a:lnR w="19050" cap="flat" cmpd="sng" algn="ctr">
-                      <a:solidFill>
-                        <a:srgbClr val="16181D"/>
-                      </a:solidFill>
-                      <a:prstDash val="solid"/>
-                      <a:round/>
-                      <a:headEnd type="none" w="med" len="med"/>
-                      <a:tailEnd type="none" w="med" len="med"/>
-                    </a:lnR>
-                    <a:lnT w="19050" cap="flat" cmpd="sng" algn="ctr">
-                      <a:solidFill>
-                        <a:srgbClr val="16181D"/>
-                      </a:solidFill>
-                      <a:prstDash val="solid"/>
-                      <a:round/>
-                      <a:headEnd type="none" w="med" len="med"/>
-                      <a:tailEnd type="none" w="med" len="med"/>
-                    </a:lnT>
-                    <a:lnB w="19050" cap="flat" cmpd="sng" algn="ctr">
-                      <a:solidFill>
-                        <a:srgbClr val="16181D"/>
-                      </a:solidFill>
-                      <a:prstDash val="solid"/>
-                      <a:round/>
-                      <a:headEnd type="none" w="med" len="med"/>
-                      <a:tailEnd type="none" w="med" len="med"/>
-                    </a:lnB>
-                    <a:solidFill>
-                      <a:srgbClr val="FBF9F3"/>
-                    </a:solidFill>
-                  </a:tcPr>
-                </a:tc>
-              </a:tr>
-              <a:tr h="431800">
-                <a:tc>
-                  <a:txBody>
-                    <a:bodyPr/>
-                    <a:lstStyle/>
-                    <a:p>
-                      <a:pPr indent="0" marL="0">
-                        <a:buNone/>
-                      </a:pPr>
-                      <a:r>
-                        <a:rPr lang="en-US" sz="1500" dirty="0">
-                          <a:solidFill>
-                            <a:srgbClr val="16181D"/>
-                          </a:solidFill>
-                          <a:latin typeface="IBM Plex Sans" pitchFamily="34" charset="0"/>
-                          <a:ea typeface="IBM Plex Sans" pitchFamily="34" charset="-122"/>
-                          <a:cs typeface="IBM Plex Sans" pitchFamily="34" charset="-120"/>
-                        </a:rPr>
-                        <a:t>Réponse &lt; 2 secondes</a:t>
-                      </a:r>
-                      <a:endParaRPr lang="en-US" sz="1500" dirty="0">
-                        <a:latin typeface="IBM Plex Sans" charset="0"/>
-                        <a:ea typeface="IBM Plex Sans" charset="0"/>
-                        <a:cs typeface="IBM Plex Sans" charset="0"/>
-                      </a:endParaRPr>
-                    </a:p>
-                  </a:txBody>
-                  <a:tcPr marL="91440" marR="91440" marT="45720" marB="45720" anchor="ctr">
-                    <a:lnL w="19050" cap="flat" cmpd="sng" algn="ctr">
-                      <a:solidFill>
-                        <a:srgbClr val="16181D"/>
-                      </a:solidFill>
-                      <a:prstDash val="solid"/>
-                      <a:round/>
-                      <a:headEnd type="none" w="med" len="med"/>
-                      <a:tailEnd type="none" w="med" len="med"/>
-                    </a:lnL>
-                    <a:lnR w="19050" cap="flat" cmpd="sng" algn="ctr">
-                      <a:solidFill>
-                        <a:srgbClr val="16181D"/>
-                      </a:solidFill>
-                      <a:prstDash val="solid"/>
-                      <a:round/>
-                      <a:headEnd type="none" w="med" len="med"/>
-                      <a:tailEnd type="none" w="med" len="med"/>
-                    </a:lnR>
-                    <a:lnT w="19050" cap="flat" cmpd="sng" algn="ctr">
-                      <a:solidFill>
-                        <a:srgbClr val="16181D"/>
-                      </a:solidFill>
-                      <a:prstDash val="solid"/>
-                      <a:round/>
-                      <a:headEnd type="none" w="med" len="med"/>
-                      <a:tailEnd type="none" w="med" len="med"/>
-                    </a:lnT>
-                    <a:lnB w="19050" cap="flat" cmpd="sng" algn="ctr">
-                      <a:solidFill>
-                        <a:srgbClr val="16181D"/>
-                      </a:solidFill>
-                      <a:prstDash val="solid"/>
-                      <a:round/>
-                      <a:headEnd type="none" w="med" len="med"/>
-                      <a:tailEnd type="none" w="med" len="med"/>
-                    </a:lnB>
-                    <a:solidFill>
-                      <a:srgbClr val="FBF9F3"/>
-                    </a:solidFill>
-                  </a:tcPr>
-                </a:tc>
-                <a:tc>
-                  <a:txBody>
-                    <a:bodyPr/>
-                    <a:lstStyle/>
-                    <a:p>
-                      <a:pPr indent="0" marL="0">
-                        <a:buNone/>
-                      </a:pPr>
-                      <a:r>
-                        <a:rPr lang="en-US" sz="1500" dirty="0">
-                          <a:solidFill>
-                            <a:srgbClr val="16181D"/>
-                          </a:solidFill>
-                          <a:latin typeface="IBM Plex Sans" pitchFamily="34" charset="0"/>
-                          <a:ea typeface="IBM Plex Sans" pitchFamily="34" charset="-122"/>
-                          <a:cs typeface="IBM Plex Sans" pitchFamily="34" charset="-120"/>
-                        </a:rPr>
-                        <a:t>Indexation PostgreSQL, à mesurer</a:t>
-                      </a:r>
-                      <a:endParaRPr lang="en-US" sz="1500" dirty="0">
-                        <a:latin typeface="IBM Plex Sans" charset="0"/>
-                        <a:ea typeface="IBM Plex Sans" charset="0"/>
-                        <a:cs typeface="IBM Plex Sans" charset="0"/>
-                      </a:endParaRPr>
-                    </a:p>
-                  </a:txBody>
-                  <a:tcPr marL="91440" marR="91440" marT="45720" marB="45720" anchor="ctr">
-                    <a:lnL w="19050" cap="flat" cmpd="sng" algn="ctr">
-                      <a:solidFill>
-                        <a:srgbClr val="16181D"/>
-                      </a:solidFill>
-                      <a:prstDash val="solid"/>
-                      <a:round/>
-                      <a:headEnd type="none" w="med" len="med"/>
-                      <a:tailEnd type="none" w="med" len="med"/>
-                    </a:lnL>
-                    <a:lnR w="19050" cap="flat" cmpd="sng" algn="ctr">
-                      <a:solidFill>
-                        <a:srgbClr val="16181D"/>
-                      </a:solidFill>
-                      <a:prstDash val="solid"/>
-                      <a:round/>
-                      <a:headEnd type="none" w="med" len="med"/>
-                      <a:tailEnd type="none" w="med" len="med"/>
-                    </a:lnR>
-                    <a:lnT w="19050" cap="flat" cmpd="sng" algn="ctr">
-                      <a:solidFill>
-                        <a:srgbClr val="16181D"/>
-                      </a:solidFill>
-                      <a:prstDash val="solid"/>
-                      <a:round/>
-                      <a:headEnd type="none" w="med" len="med"/>
-                      <a:tailEnd type="none" w="med" len="med"/>
-                    </a:lnT>
-                    <a:lnB w="19050" cap="flat" cmpd="sng" algn="ctr">
-                      <a:solidFill>
-                        <a:srgbClr val="16181D"/>
-                      </a:solidFill>
-                      <a:prstDash val="solid"/>
-                      <a:round/>
-                      <a:headEnd type="none" w="med" len="med"/>
-                      <a:tailEnd type="none" w="med" len="med"/>
-                    </a:lnB>
-                    <a:solidFill>
-                      <a:srgbClr val="FBF9F3"/>
-                    </a:solidFill>
-                  </a:tcPr>
-                </a:tc>
-                <a:tc>
-                  <a:txBody>
-                    <a:bodyPr/>
-                    <a:lstStyle/>
-                    <a:p>
-                      <a:pPr indent="0" marL="0">
-                        <a:buNone/>
-                      </a:pPr>
-                      <a:r>
-                        <a:rPr lang="en-US" sz="1500" b="1" dirty="0">
-                          <a:solidFill>
-                            <a:srgbClr val="16181D"/>
-                          </a:solidFill>
-                          <a:latin typeface="IBM Plex Sans" pitchFamily="34" charset="0"/>
-                          <a:ea typeface="IBM Plex Sans" pitchFamily="34" charset="-122"/>
-                          <a:cs typeface="IBM Plex Sans" pitchFamily="34" charset="-120"/>
-                        </a:rPr>
-                        <a:t>À mesurer</a:t>
+                        <a:t>En cours</a:t>
                       </a:r>
                       <a:endParaRPr lang="en-US" sz="1500" dirty="0">
                         <a:latin typeface="IBM Plex Sans" charset="0"/>
@@ -6118,7 +6118,7 @@
                 <a:ea typeface="Space Grotesk" pitchFamily="34" charset="-122"/>
                 <a:cs typeface="Space Grotesk" pitchFamily="34" charset="-120"/>
               </a:rPr>
-              <a:t>Compétences et retour critique</a:t>
+              <a:t>Compétences et adaptabilité</a:t>
             </a:r>
             <a:endParaRPr lang="en-US" sz="3600" dirty="0"/>
           </a:p>
@@ -6402,7 +6402,7 @@
                 <a:ea typeface="Space Grotesk" pitchFamily="34" charset="-122"/>
                 <a:cs typeface="Space Grotesk" pitchFamily="34" charset="-120"/>
               </a:rPr>
-              <a:t>Retour critique</a:t>
+              <a:t>Adaptabilité</a:t>
             </a:r>
             <a:endParaRPr lang="en-US" sz="2000" dirty="0"/>
           </a:p>
@@ -6444,7 +6444,7 @@
                 <a:ea typeface="IBM Plex Sans" pitchFamily="34" charset="-122"/>
                 <a:cs typeface="IBM Plex Sans" pitchFamily="34" charset="-120"/>
               </a:rPr>
-              <a:t>Le planning initial ne prévoyait pas de marge pour les imprévus : le projet Logtis passé en P1 et les fichiers hétérogènes ont décalé la mise en production.</a:t>
+              <a:t>Trois imprévus (Logtis en P1, fichiers hétérogènes, alerte sur Nexus) : j’ai su prioriser, arbitrer et adapter le planning, et RIPTIS est en production.</a:t>
             </a:r>
             <a:endParaRPr lang="en-US" sz="1600" dirty="0"/>
           </a:p>
@@ -6486,7 +6486,7 @@
                 <a:ea typeface="IBM Plex Sans" pitchFamily="34" charset="-122"/>
                 <a:cs typeface="IBM Plex Sans" pitchFamily="34" charset="-120"/>
               </a:rPr>
-              <a:t>Prévoir une marge pour les imprévus dès la construction du planning.</a:t>
+              <a:t>Réflexe acquis : prévoir une marge pour les imprévus dès la construction du planning.</a:t>
             </a:r>
             <a:endParaRPr lang="en-US" sz="1600" dirty="0"/>
           </a:p>
@@ -8117,8 +8117,8 @@
         </p:nvSpPr>
         <p:spPr>
           <a:xfrm>
-            <a:off x="812800" y="5080000"/>
-            <a:ext cx="6604000" cy="825500"/>
+            <a:off x="812800" y="4889500"/>
+            <a:ext cx="6604000" cy="889000"/>
           </a:xfrm>
           <a:prstGeom prst="rect">
             <a:avLst/>
@@ -8131,10 +8131,13 @@
           <a:lstStyle/>
           <a:p>
             <a:pPr indent="0" marL="0">
+              <a:lnSpc>
+                <a:spcPct val="95000"/>
+              </a:lnSpc>
               <a:buNone/>
             </a:pPr>
             <a:r>
-              <a:rPr lang="en-US" sz="4800" b="1" dirty="0">
+              <a:rPr lang="en-US" sz="2800" b="1" dirty="0">
                 <a:solidFill>
                   <a:srgbClr val="16181D"/>
                 </a:solidFill>
@@ -8142,9 +8145,48 @@
                 <a:ea typeface="Space Grotesk" pitchFamily="34" charset="-122"/>
                 <a:cs typeface="Space Grotesk" pitchFamily="34" charset="-120"/>
               </a:rPr>
-              <a:t>Merci.</a:t>
+              <a:t>Et si retrouver un flux réseau prenait 30 secondes ?</a:t>
             </a:r>
-            <a:endParaRPr lang="en-US" sz="4800" dirty="0"/>
+            <a:endParaRPr lang="en-US" sz="2800" dirty="0"/>
+          </a:p>
+        </p:txBody>
+      </p:sp>
+      <p:sp>
+        <p:nvSpPr>
+          <p:cNvPr id="19" name="Text 14"/>
+          <p:cNvSpPr txBox="1"/>
+          <p:nvPr/>
+        </p:nvSpPr>
+        <p:spPr>
+          <a:xfrm>
+            <a:off x="812800" y="5810250"/>
+            <a:ext cx="6604000" cy="228600"/>
+          </a:xfrm>
+          <a:prstGeom prst="rect">
+            <a:avLst/>
+          </a:prstGeom>
+          <a:noFill/>
+          <a:ln/>
+        </p:spPr>
+        <p:txBody>
+          <a:bodyPr wrap="square" lIns="0" tIns="0" rIns="0" bIns="0" rtlCol="0" anchor="t"/>
+          <a:lstStyle/>
+          <a:p>
+            <a:pPr indent="0" marL="0">
+              <a:buNone/>
+            </a:pPr>
+            <a:r>
+              <a:rPr lang="en-US" sz="1400" dirty="0">
+                <a:solidFill>
+                  <a:srgbClr val="4B5159"/>
+                </a:solidFill>
+                <a:latin typeface="IBM Plex Sans" pitchFamily="34" charset="0"/>
+                <a:ea typeface="IBM Plex Sans" pitchFamily="34" charset="-122"/>
+                <a:cs typeface="IBM Plex Sans" pitchFamily="34" charset="-120"/>
+              </a:rPr>
+              <a:t>Merci de votre attention.</a:t>
+            </a:r>
+            <a:endParaRPr lang="en-US" sz="1400" dirty="0"/>
           </a:p>
         </p:txBody>
       </p:sp>
@@ -14709,7 +14751,7 @@
                 <a:ea typeface="Space Grotesk" pitchFamily="34" charset="-122"/>
                 <a:cs typeface="Space Grotesk" pitchFamily="34" charset="-120"/>
               </a:rPr>
-              <a:t>Un mois de décalage en fin de projet</a:t>
+              <a:t>Planning prévisionnel et réalisé</a:t>
             </a:r>
             <a:endParaRPr lang="en-US" sz="3600" dirty="0"/>
           </a:p>
@@ -15278,7 +15320,7 @@
                 <a:ea typeface="Space Grotesk" pitchFamily="34" charset="-122"/>
                 <a:cs typeface="Space Grotesk" pitchFamily="34" charset="-120"/>
               </a:rPr>
-              <a:t>Deux imprévus, un arbitrage</a:t>
+              <a:t>Trois imprévus, un projet livré</a:t>
             </a:r>
             <a:endParaRPr lang="en-US" sz="3600" dirty="0"/>
           </a:p>
@@ -15293,7 +15335,7 @@
         <p:spPr>
           <a:xfrm>
             <a:off x="812800" y="1587500"/>
-            <a:ext cx="5156200" cy="2540000"/>
+            <a:ext cx="3384550" cy="2730500"/>
           </a:xfrm>
           <a:prstGeom prst="rect">
             <a:avLst/>
@@ -15325,7 +15367,7 @@
         <p:spPr>
           <a:xfrm>
             <a:off x="1041400" y="1816100"/>
-            <a:ext cx="3810000" cy="215900"/>
+            <a:ext cx="2921000" cy="215900"/>
           </a:xfrm>
           <a:prstGeom prst="rect">
             <a:avLst/>
@@ -15364,7 +15406,7 @@
         <p:spPr>
           <a:xfrm>
             <a:off x="1041400" y="2133600"/>
-            <a:ext cx="4699000" cy="355600"/>
+            <a:ext cx="2927350" cy="355600"/>
           </a:xfrm>
           <a:prstGeom prst="rect">
             <a:avLst/>
@@ -15380,7 +15422,7 @@
               <a:buNone/>
             </a:pPr>
             <a:r>
-              <a:rPr lang="en-US" sz="2000" b="1" dirty="0">
+              <a:rPr lang="en-US" sz="1800" b="1" dirty="0">
                 <a:solidFill>
                   <a:srgbClr val="16181D"/>
                 </a:solidFill>
@@ -15388,9 +15430,9 @@
                 <a:ea typeface="Space Grotesk" pitchFamily="34" charset="-122"/>
                 <a:cs typeface="Space Grotesk" pitchFamily="34" charset="-120"/>
               </a:rPr>
-              <a:t>Projet Logtis prioritaire</a:t>
+              <a:t>Projet Logtis en P1</a:t>
             </a:r>
-            <a:endParaRPr lang="en-US" sz="2000" dirty="0"/>
+            <a:endParaRPr lang="en-US" sz="1800" dirty="0"/>
           </a:p>
         </p:txBody>
       </p:sp>
@@ -15402,8 +15444,8 @@
         </p:nvSpPr>
         <p:spPr>
           <a:xfrm>
-            <a:off x="1041400" y="2667000"/>
-            <a:ext cx="4699000" cy="1270000"/>
+            <a:off x="1041400" y="2603500"/>
+            <a:ext cx="2927350" cy="1587500"/>
           </a:xfrm>
           <a:prstGeom prst="rect">
             <a:avLst/>
@@ -15422,7 +15464,7 @@
               <a:buNone/>
             </a:pPr>
             <a:r>
-              <a:rPr lang="en-US" sz="1600" dirty="0">
+              <a:rPr lang="en-US" sz="1400" dirty="0">
                 <a:solidFill>
                   <a:srgbClr val="16181D"/>
                 </a:solidFill>
@@ -15430,9 +15472,9 @@
                 <a:ea typeface="IBM Plex Sans" pitchFamily="34" charset="-122"/>
                 <a:cs typeface="IBM Plex Sans" pitchFamily="34" charset="-120"/>
               </a:rPr>
-              <a:t>Un projet Logtis, passé en P1 devant RIPTIS, a décalé les tâches de RIPTIS.</a:t>
+              <a:t>Un projet Logtis, passé en priorité P1 devant RIPTIS, a décalé les tâches de RIPTIS.</a:t>
             </a:r>
-            <a:endParaRPr lang="en-US" sz="1600" dirty="0"/>
+            <a:endParaRPr lang="en-US" sz="1400" dirty="0"/>
           </a:p>
         </p:txBody>
       </p:sp>
@@ -15444,8 +15486,8 @@
         </p:nvSpPr>
         <p:spPr>
           <a:xfrm>
-            <a:off x="6223000" y="1587500"/>
-            <a:ext cx="5156200" cy="2540000"/>
+            <a:off x="4400550" y="1587500"/>
+            <a:ext cx="3384550" cy="2730500"/>
           </a:xfrm>
           <a:prstGeom prst="rect">
             <a:avLst/>
@@ -15476,8 +15518,8 @@
         </p:nvSpPr>
         <p:spPr>
           <a:xfrm>
-            <a:off x="6451600" y="1816100"/>
-            <a:ext cx="3810000" cy="215900"/>
+            <a:off x="4629150" y="1816100"/>
+            <a:ext cx="2921000" cy="215900"/>
           </a:xfrm>
           <a:prstGeom prst="rect">
             <a:avLst/>
@@ -15515,8 +15557,8 @@
         </p:nvSpPr>
         <p:spPr>
           <a:xfrm>
-            <a:off x="6451600" y="2133600"/>
-            <a:ext cx="4699000" cy="355600"/>
+            <a:off x="4629150" y="2133600"/>
+            <a:ext cx="2927350" cy="355600"/>
           </a:xfrm>
           <a:prstGeom prst="rect">
             <a:avLst/>
@@ -15532,7 +15574,7 @@
               <a:buNone/>
             </a:pPr>
             <a:r>
-              <a:rPr lang="en-US" sz="2000" b="1" dirty="0">
+              <a:rPr lang="en-US" sz="1800" b="1" dirty="0">
                 <a:solidFill>
                   <a:srgbClr val="16181D"/>
                 </a:solidFill>
@@ -15542,7 +15584,7 @@
               </a:rPr>
               <a:t>Fichiers hétérogènes</a:t>
             </a:r>
-            <a:endParaRPr lang="en-US" sz="2000" dirty="0"/>
+            <a:endParaRPr lang="en-US" sz="1800" dirty="0"/>
           </a:p>
         </p:txBody>
       </p:sp>
@@ -15554,8 +15596,8 @@
         </p:nvSpPr>
         <p:spPr>
           <a:xfrm>
-            <a:off x="6451600" y="2667000"/>
-            <a:ext cx="4699000" cy="1270000"/>
+            <a:off x="4629150" y="2603500"/>
+            <a:ext cx="2927350" cy="1587500"/>
           </a:xfrm>
           <a:prstGeom prst="rect">
             <a:avLst/>
@@ -15574,7 +15616,7 @@
               <a:buNone/>
             </a:pPr>
             <a:r>
-              <a:rPr lang="en-US" sz="1600" dirty="0">
+              <a:rPr lang="en-US" sz="1400" dirty="0">
                 <a:solidFill>
                   <a:srgbClr val="16181D"/>
                 </a:solidFill>
@@ -15584,7 +15626,7 @@
               </a:rPr>
               <a:t>Structures variées, jusqu’à 2003. Une vingtaine de fichiers particuliers identifiés en test.</a:t>
             </a:r>
-            <a:endParaRPr lang="en-US" sz="1600" dirty="0"/>
+            <a:endParaRPr lang="en-US" sz="1400" dirty="0"/>
           </a:p>
         </p:txBody>
       </p:sp>
@@ -15596,8 +15638,160 @@
         </p:nvSpPr>
         <p:spPr>
           <a:xfrm>
-            <a:off x="812800" y="4572000"/>
-            <a:ext cx="10566400" cy="1016000"/>
+            <a:off x="7988300" y="1587500"/>
+            <a:ext cx="3384550" cy="2730500"/>
+          </a:xfrm>
+          <a:prstGeom prst="rect">
+            <a:avLst/>
+          </a:prstGeom>
+          <a:solidFill>
+            <a:srgbClr val="FBF9F3"/>
+          </a:solidFill>
+          <a:ln w="25400">
+            <a:solidFill>
+              <a:srgbClr val="16181D"/>
+            </a:solidFill>
+            <a:prstDash val="solid"/>
+          </a:ln>
+          <a:effectLst>
+            <a:outerShdw sx="100000" sy="100000" kx="0" ky="0" algn="bl" rotWithShape="0" blurRad="101600" dist="63500" dir="2700000">
+              <a:srgbClr val="16181D">
+                <a:alpha val="100000"/>
+              </a:srgbClr>
+            </a:outerShdw>
+          </a:effectLst>
+        </p:spPr>
+      </p:sp>
+      <p:sp>
+        <p:nvSpPr>
+          <p:cNvPr id="20" name="Text 15"/>
+          <p:cNvSpPr txBox="1"/>
+          <p:nvPr/>
+        </p:nvSpPr>
+        <p:spPr>
+          <a:xfrm>
+            <a:off x="8216900" y="1816100"/>
+            <a:ext cx="2921000" cy="215900"/>
+          </a:xfrm>
+          <a:prstGeom prst="rect">
+            <a:avLst/>
+          </a:prstGeom>
+          <a:noFill/>
+          <a:ln/>
+        </p:spPr>
+        <p:txBody>
+          <a:bodyPr wrap="square" lIns="0" tIns="0" rIns="0" bIns="0" rtlCol="0" anchor="t"/>
+          <a:lstStyle/>
+          <a:p>
+            <a:pPr indent="0" marL="0">
+              <a:buNone/>
+            </a:pPr>
+            <a:r>
+              <a:rPr lang="en-US" sz="1200" b="1" spc="200" kern="0" dirty="0">
+                <a:solidFill>
+                  <a:srgbClr val="0B4F7A"/>
+                </a:solidFill>
+                <a:latin typeface="JetBrains Mono" pitchFamily="34" charset="0"/>
+                <a:ea typeface="JetBrains Mono" pitchFamily="34" charset="-122"/>
+                <a:cs typeface="JetBrains Mono" pitchFamily="34" charset="-120"/>
+              </a:rPr>
+              <a:t>IMPRÉVU 03</a:t>
+            </a:r>
+            <a:endParaRPr lang="en-US" sz="1200" dirty="0"/>
+          </a:p>
+        </p:txBody>
+      </p:sp>
+      <p:sp>
+        <p:nvSpPr>
+          <p:cNvPr id="21" name="Text 16"/>
+          <p:cNvSpPr txBox="1"/>
+          <p:nvPr/>
+        </p:nvSpPr>
+        <p:spPr>
+          <a:xfrm>
+            <a:off x="8216900" y="2133600"/>
+            <a:ext cx="2927350" cy="355600"/>
+          </a:xfrm>
+          <a:prstGeom prst="rect">
+            <a:avLst/>
+          </a:prstGeom>
+          <a:noFill/>
+          <a:ln/>
+        </p:spPr>
+        <p:txBody>
+          <a:bodyPr wrap="square" lIns="0" tIns="0" rIns="0" bIns="0" rtlCol="0" anchor="t"/>
+          <a:lstStyle/>
+          <a:p>
+            <a:pPr indent="0" marL="0">
+              <a:buNone/>
+            </a:pPr>
+            <a:r>
+              <a:rPr lang="en-US" sz="1800" b="1" dirty="0">
+                <a:solidFill>
+                  <a:srgbClr val="16181D"/>
+                </a:solidFill>
+                <a:latin typeface="Space Grotesk" pitchFamily="34" charset="0"/>
+                <a:ea typeface="Space Grotesk" pitchFamily="34" charset="-122"/>
+                <a:cs typeface="Space Grotesk" pitchFamily="34" charset="-120"/>
+              </a:rPr>
+              <a:t>Alerte sur Nexus</a:t>
+            </a:r>
+            <a:endParaRPr lang="en-US" sz="1800" dirty="0"/>
+          </a:p>
+        </p:txBody>
+      </p:sp>
+      <p:sp>
+        <p:nvSpPr>
+          <p:cNvPr id="22" name="Text 17"/>
+          <p:cNvSpPr txBox="1"/>
+          <p:nvPr/>
+        </p:nvSpPr>
+        <p:spPr>
+          <a:xfrm>
+            <a:off x="8216900" y="2603500"/>
+            <a:ext cx="2927350" cy="1587500"/>
+          </a:xfrm>
+          <a:prstGeom prst="rect">
+            <a:avLst/>
+          </a:prstGeom>
+          <a:noFill/>
+          <a:ln/>
+        </p:spPr>
+        <p:txBody>
+          <a:bodyPr wrap="square" lIns="0" tIns="0" rIns="0" bIns="0" rtlCol="0" anchor="t"/>
+          <a:lstStyle/>
+          <a:p>
+            <a:pPr indent="0" marL="0">
+              <a:lnSpc>
+                <a:spcPct val="105000"/>
+              </a:lnSpc>
+              <a:buNone/>
+            </a:pPr>
+            <a:r>
+              <a:rPr lang="en-US" sz="1400" dirty="0">
+                <a:solidFill>
+                  <a:srgbClr val="16181D"/>
+                </a:solidFill>
+                <a:latin typeface="IBM Plex Sans" pitchFamily="34" charset="0"/>
+                <a:ea typeface="IBM Plex Sans" pitchFamily="34" charset="-122"/>
+                <a:cs typeface="IBM Plex Sans" pitchFamily="34" charset="-120"/>
+              </a:rPr>
+              <a:t>Une instance externe a alerté Transactis sur des vulnérabilités potentielles de Nexus, l’outil de gestion des librairies. Il a fallu cesser de l’utiliser et trouver une alternative pour installer les packages.</a:t>
+            </a:r>
+            <a:endParaRPr lang="en-US" sz="1400" dirty="0"/>
+          </a:p>
+        </p:txBody>
+      </p:sp>
+      <p:sp>
+        <p:nvSpPr>
+          <p:cNvPr id="23" name="Shape 18"/>
+          <p:cNvSpPr/>
+          <p:nvPr/>
+        </p:nvSpPr>
+        <p:spPr>
+          <a:xfrm>
+            <a:off x="812800" y="4699000"/>
+            <a:ext cx="10566400" cy="952500"/>
           </a:xfrm>
           <a:prstGeom prst="rect">
             <a:avLst/>
@@ -15610,14 +15804,14 @@
       </p:sp>
       <p:sp>
         <p:nvSpPr>
-          <p:cNvPr id="20" name="Text 15"/>
+          <p:cNvPr id="24" name="Text 19"/>
           <p:cNvSpPr txBox="1"/>
           <p:nvPr/>
         </p:nvSpPr>
         <p:spPr>
           <a:xfrm>
-            <a:off x="1066800" y="4572000"/>
-            <a:ext cx="10058400" cy="1016000"/>
+            <a:off x="1066800" y="4699000"/>
+            <a:ext cx="10058400" cy="952500"/>
           </a:xfrm>
           <a:prstGeom prst="rect">
             <a:avLst/>
@@ -15641,7 +15835,7 @@
                 <a:ea typeface="Space Grotesk" pitchFamily="34" charset="-122"/>
                 <a:cs typeface="Space Grotesk" pitchFamily="34" charset="-120"/>
               </a:rPr>
-              <a:t>Arbitrage : privilégier la robustesse du moteur d’import plutôt que le calendrier initial.</a:t>
+              <a:t>Face aux imprévus : prioriser, arbitrer et privilégier la robustesse plutôt que le calendrier initial.</a:t>
             </a:r>
             <a:endParaRPr lang="en-US" sz="2000" dirty="0"/>
           </a:p>
@@ -16043,8 +16237,47 @@
         </p:nvSpPr>
         <p:spPr>
           <a:xfrm>
-            <a:off x="7213600" y="2159000"/>
-            <a:ext cx="4165600" cy="2667000"/>
+            <a:off x="7213600" y="2044700"/>
+            <a:ext cx="4165600" cy="215900"/>
+          </a:xfrm>
+          <a:prstGeom prst="rect">
+            <a:avLst/>
+          </a:prstGeom>
+          <a:noFill/>
+          <a:ln/>
+        </p:spPr>
+        <p:txBody>
+          <a:bodyPr wrap="square" lIns="0" tIns="0" rIns="0" bIns="0" rtlCol="0" anchor="t"/>
+          <a:lstStyle/>
+          <a:p>
+            <a:pPr indent="0" marL="0">
+              <a:buNone/>
+            </a:pPr>
+            <a:r>
+              <a:rPr lang="en-US" sz="1200" b="1" spc="200" kern="0" dirty="0">
+                <a:solidFill>
+                  <a:srgbClr val="0B4F7A"/>
+                </a:solidFill>
+                <a:latin typeface="JetBrains Mono" pitchFamily="34" charset="0"/>
+                <a:ea typeface="JetBrains Mono" pitchFamily="34" charset="-122"/>
+                <a:cs typeface="JetBrains Mono" pitchFamily="34" charset="-120"/>
+              </a:rPr>
+              <a:t>SOCLE INITIAL</a:t>
+            </a:r>
+            <a:endParaRPr lang="en-US" sz="1200" dirty="0"/>
+          </a:p>
+        </p:txBody>
+      </p:sp>
+      <p:sp>
+        <p:nvSpPr>
+          <p:cNvPr id="15" name="Text 9"/>
+          <p:cNvSpPr txBox="1"/>
+          <p:nvPr/>
+        </p:nvSpPr>
+        <p:spPr>
+          <a:xfrm>
+            <a:off x="7213600" y="2298700"/>
+            <a:ext cx="4165600" cy="1460500"/>
           </a:xfrm>
           <a:prstGeom prst="rect">
             <a:avLst/>
@@ -16064,7 +16297,7 @@
               <a:buChar char="•"/>
             </a:pPr>
             <a:r>
-              <a:rPr lang="en-US" sz="1600" dirty="0">
+              <a:rPr lang="en-US" sz="1400" dirty="0">
                 <a:solidFill>
                   <a:srgbClr val="16181D"/>
                 </a:solidFill>
@@ -16074,7 +16307,7 @@
               </a:rPr>
               <a:t>Import Excel multi-formats</a:t>
             </a:r>
-            <a:endParaRPr lang="en-US" sz="1600" dirty="0"/>
+            <a:endParaRPr lang="en-US" sz="1400" dirty="0"/>
           </a:p>
           <a:p>
             <a:pPr marL="279400" indent="-279400">
@@ -16085,7 +16318,7 @@
               <a:buChar char="•"/>
             </a:pPr>
             <a:r>
-              <a:rPr lang="en-US" sz="1600" dirty="0">
+              <a:rPr lang="en-US" sz="1400" dirty="0">
                 <a:solidFill>
                   <a:srgbClr val="16181D"/>
                 </a:solidFill>
@@ -16095,7 +16328,7 @@
               </a:rPr>
               <a:t>Recherche multicritère</a:t>
             </a:r>
-            <a:endParaRPr lang="en-US" sz="1600" dirty="0"/>
+            <a:endParaRPr lang="en-US" sz="1400" dirty="0"/>
           </a:p>
           <a:p>
             <a:pPr marL="279400" indent="-279400">
@@ -16106,7 +16339,131 @@
               <a:buChar char="•"/>
             </a:pPr>
             <a:r>
-              <a:rPr lang="en-US" sz="1600" dirty="0">
+              <a:rPr lang="en-US" sz="1400" dirty="0">
+                <a:solidFill>
+                  <a:srgbClr val="16181D"/>
+                </a:solidFill>
+                <a:latin typeface="IBM Plex Sans" pitchFamily="34" charset="0"/>
+                <a:ea typeface="IBM Plex Sans" pitchFamily="34" charset="-122"/>
+                <a:cs typeface="IBM Plex Sans" pitchFamily="34" charset="-120"/>
+              </a:rPr>
+              <a:t>Export Excel</a:t>
+            </a:r>
+            <a:endParaRPr lang="en-US" sz="1400" dirty="0"/>
+          </a:p>
+          <a:p>
+            <a:pPr marL="279400" indent="-279400">
+              <a:spcAft>
+                <a:spcPts val="800"/>
+              </a:spcAft>
+              <a:buSzPct val="100000"/>
+              <a:buChar char="•"/>
+            </a:pPr>
+            <a:r>
+              <a:rPr lang="en-US" sz="1400" dirty="0">
+                <a:solidFill>
+                  <a:srgbClr val="16181D"/>
+                </a:solidFill>
+                <a:latin typeface="IBM Plex Sans" pitchFamily="34" charset="0"/>
+                <a:ea typeface="IBM Plex Sans" pitchFamily="34" charset="-122"/>
+                <a:cs typeface="IBM Plex Sans" pitchFamily="34" charset="-120"/>
+              </a:rPr>
+              <a:t>Droits par OIDC</a:t>
+            </a:r>
+            <a:endParaRPr lang="en-US" sz="1400" dirty="0"/>
+          </a:p>
+          <a:p>
+            <a:pPr marL="279400" indent="-279400">
+              <a:spcAft>
+                <a:spcPts val="800"/>
+              </a:spcAft>
+              <a:buSzPct val="100000"/>
+              <a:buChar char="•"/>
+            </a:pPr>
+            <a:r>
+              <a:rPr lang="en-US" sz="1400" dirty="0">
+                <a:solidFill>
+                  <a:srgbClr val="16181D"/>
+                </a:solidFill>
+                <a:latin typeface="IBM Plex Sans" pitchFamily="34" charset="0"/>
+                <a:ea typeface="IBM Plex Sans" pitchFamily="34" charset="-122"/>
+                <a:cs typeface="IBM Plex Sans" pitchFamily="34" charset="-120"/>
+              </a:rPr>
+              <a:t>Sauvegarde PostgreSQL</a:t>
+            </a:r>
+            <a:endParaRPr lang="en-US" sz="1400" dirty="0"/>
+          </a:p>
+        </p:txBody>
+      </p:sp>
+      <p:sp>
+        <p:nvSpPr>
+          <p:cNvPr id="16" name="Text 10"/>
+          <p:cNvSpPr txBox="1"/>
+          <p:nvPr/>
+        </p:nvSpPr>
+        <p:spPr>
+          <a:xfrm>
+            <a:off x="7213600" y="3911600"/>
+            <a:ext cx="4165600" cy="215900"/>
+          </a:xfrm>
+          <a:prstGeom prst="rect">
+            <a:avLst/>
+          </a:prstGeom>
+          <a:noFill/>
+          <a:ln/>
+        </p:spPr>
+        <p:txBody>
+          <a:bodyPr wrap="square" lIns="0" tIns="0" rIns="0" bIns="0" rtlCol="0" anchor="t"/>
+          <a:lstStyle/>
+          <a:p>
+            <a:pPr indent="0" marL="0">
+              <a:buNone/>
+            </a:pPr>
+            <a:r>
+              <a:rPr lang="en-US" sz="1200" b="1" spc="200" kern="0" dirty="0">
+                <a:solidFill>
+                  <a:srgbClr val="0B4F7A"/>
+                </a:solidFill>
+                <a:latin typeface="JetBrains Mono" pitchFamily="34" charset="0"/>
+                <a:ea typeface="JetBrains Mono" pitchFamily="34" charset="-122"/>
+                <a:cs typeface="JetBrains Mono" pitchFamily="34" charset="-120"/>
+              </a:rPr>
+              <a:t>AJOUTS EN COURS DE PROJET</a:t>
+            </a:r>
+            <a:endParaRPr lang="en-US" sz="1200" dirty="0"/>
+          </a:p>
+        </p:txBody>
+      </p:sp>
+      <p:sp>
+        <p:nvSpPr>
+          <p:cNvPr id="17" name="Text 11"/>
+          <p:cNvSpPr txBox="1"/>
+          <p:nvPr/>
+        </p:nvSpPr>
+        <p:spPr>
+          <a:xfrm>
+            <a:off x="7213600" y="4165600"/>
+            <a:ext cx="4165600" cy="1270000"/>
+          </a:xfrm>
+          <a:prstGeom prst="rect">
+            <a:avLst/>
+          </a:prstGeom>
+          <a:noFill/>
+          <a:ln/>
+        </p:spPr>
+        <p:txBody>
+          <a:bodyPr wrap="square" lIns="0" tIns="0" rIns="0" bIns="0" rtlCol="0" anchor="t"/>
+          <a:lstStyle/>
+          <a:p>
+            <a:pPr marL="279400" indent="-279400">
+              <a:spcAft>
+                <a:spcPts val="800"/>
+              </a:spcAft>
+              <a:buSzPct val="100000"/>
+              <a:buChar char="•"/>
+            </a:pPr>
+            <a:r>
+              <a:rPr lang="en-US" sz="1400" dirty="0">
                 <a:solidFill>
                   <a:srgbClr val="16181D"/>
                 </a:solidFill>
@@ -16116,7 +16473,7 @@
               </a:rPr>
               <a:t>Recherche DNS</a:t>
             </a:r>
-            <a:endParaRPr lang="en-US" sz="1600" dirty="0"/>
+            <a:endParaRPr lang="en-US" sz="1400" dirty="0"/>
           </a:p>
           <a:p>
             <a:pPr marL="279400" indent="-279400">
@@ -16127,7 +16484,7 @@
               <a:buChar char="•"/>
             </a:pPr>
             <a:r>
-              <a:rPr lang="en-US" sz="1600" dirty="0">
+              <a:rPr lang="en-US" sz="1400" dirty="0">
                 <a:solidFill>
                   <a:srgbClr val="16181D"/>
                 </a:solidFill>
@@ -16135,9 +16492,9 @@
                 <a:ea typeface="IBM Plex Sans" pitchFamily="34" charset="-122"/>
                 <a:cs typeface="IBM Plex Sans" pitchFamily="34" charset="-120"/>
               </a:rPr>
-              <a:t>Droits par OIDC</a:t>
+              <a:t>VPN</a:t>
             </a:r>
-            <a:endParaRPr lang="en-US" sz="1600" dirty="0"/>
+            <a:endParaRPr lang="en-US" sz="1400" dirty="0"/>
           </a:p>
           <a:p>
             <a:pPr marL="279400" indent="-279400">
@@ -16148,7 +16505,7 @@
               <a:buChar char="•"/>
             </a:pPr>
             <a:r>
-              <a:rPr lang="en-US" sz="1600" dirty="0">
+              <a:rPr lang="en-US" sz="1400" dirty="0">
                 <a:solidFill>
                   <a:srgbClr val="16181D"/>
                 </a:solidFill>
@@ -16156,9 +16513,9 @@
                 <a:ea typeface="IBM Plex Sans" pitchFamily="34" charset="-122"/>
                 <a:cs typeface="IBM Plex Sans" pitchFamily="34" charset="-120"/>
               </a:rPr>
-              <a:t>Export Excel</a:t>
+              <a:t>RSSI</a:t>
             </a:r>
-            <a:endParaRPr lang="en-US" sz="1600" dirty="0"/>
+            <a:endParaRPr lang="en-US" sz="1400" dirty="0"/>
           </a:p>
           <a:p>
             <a:pPr marL="279400" indent="-279400">
@@ -16169,7 +16526,7 @@
               <a:buChar char="•"/>
             </a:pPr>
             <a:r>
-              <a:rPr lang="en-US" sz="1600" dirty="0">
+              <a:rPr lang="en-US" sz="1400" dirty="0">
                 <a:solidFill>
                   <a:srgbClr val="16181D"/>
                 </a:solidFill>
@@ -16177,9 +16534,9 @@
                 <a:ea typeface="IBM Plex Sans" pitchFamily="34" charset="-122"/>
                 <a:cs typeface="IBM Plex Sans" pitchFamily="34" charset="-120"/>
               </a:rPr>
-              <a:t>Sauvegarde PostgreSQL</a:t>
+              <a:t>REF IP</a:t>
             </a:r>
-            <a:endParaRPr lang="en-US" sz="1600" dirty="0"/>
+            <a:endParaRPr lang="en-US" sz="1400" dirty="0"/>
           </a:p>
         </p:txBody>
       </p:sp>

</xml_diff>